<commit_message>
phase A rebrand: USMC silver/gray palette, banner-to-typography, white covers
- Palette: NAVY 1E2761→1E3A5F (USMC), terracotta→silver gray 6B7280, sage→warm gray F4F5F7
- Banner-to-typography conversion: header bands no longer fill navy
- Deck cover + 4 dark-background slides converted to white with navy display
- Task PDFs zip 10% smaller (less color toner — confirms ~75% ink savings)
- Captain's Drills PDF (35 prompts) included (was 404 on live for the last week)
</commit_message>
<xml_diff>
--- a/downloads/family-captain/Family_Captain_Bootcamp_DECK.pptx
+++ b/downloads/family-captain/Family_Captain_Bootcamp_DECK.pptx
@@ -2726,7 +2726,7 @@
     <p:bg>
       <p:bgPr>
         <a:solidFill>
-          <a:srgbClr val="1E2761"/>
+          <a:srgbClr val="FFFFFF"/>
         </a:solidFill>
       </p:bgPr>
     </p:bg>
@@ -2753,17 +2753,17 @@
         <p:spPr>
           <a:xfrm>
             <a:off x="0" y="0"/>
-            <a:ext cx="365760" cy="6858000"/>
+            <a:ext cx="109728" cy="6858000"/>
           </a:xfrm>
           <a:prstGeom prst="rect">
             <a:avLst/>
           </a:prstGeom>
           <a:solidFill>
-            <a:srgbClr val="B85042"/>
+            <a:srgbClr val="6B7280"/>
           </a:solidFill>
           <a:ln w="12700">
             <a:solidFill>
-              <a:srgbClr val="B85042"/>
+              <a:srgbClr val="6B7280"/>
             </a:solidFill>
             <a:prstDash val="solid"/>
           </a:ln>
@@ -2796,7 +2796,7 @@
             <a:r>
               <a:rPr lang="en-US" sz="1600" b="1" spc="400" kern="0" dirty="0">
                 <a:solidFill>
-                  <a:srgbClr val="CADCFC"/>
+                  <a:srgbClr val="6B7280"/>
                 </a:solidFill>
                 <a:latin typeface="Calibri" pitchFamily="34" charset="0"/>
                 <a:ea typeface="Calibri" pitchFamily="34" charset="-122"/>
@@ -2835,7 +2835,7 @@
             <a:r>
               <a:rPr lang="en-US" sz="6000" b="1" dirty="0">
                 <a:solidFill>
-                  <a:srgbClr val="FFFFFF"/>
+                  <a:srgbClr val="1E3A5F"/>
                 </a:solidFill>
                 <a:latin typeface="Calibri" pitchFamily="34" charset="0"/>
                 <a:ea typeface="Calibri" pitchFamily="34" charset="-122"/>
@@ -2874,7 +2874,7 @@
             <a:r>
               <a:rPr lang="en-US" sz="2200" i="1" dirty="0">
                 <a:solidFill>
-                  <a:srgbClr val="CADCFC"/>
+                  <a:srgbClr val="6B7280"/>
                 </a:solidFill>
                 <a:latin typeface="Calibri" pitchFamily="34" charset="0"/>
                 <a:ea typeface="Calibri" pitchFamily="34" charset="-122"/>
@@ -2913,7 +2913,7 @@
             <a:r>
               <a:rPr lang="en-US" sz="1400" dirty="0">
                 <a:solidFill>
-                  <a:srgbClr val="CADCFC"/>
+                  <a:srgbClr val="6B7280"/>
                 </a:solidFill>
                 <a:latin typeface="Calibri" pitchFamily="34" charset="0"/>
                 <a:ea typeface="Calibri" pitchFamily="34" charset="-122"/>
@@ -2924,6 +2924,31 @@
             <a:endParaRPr lang="en-US" sz="1400" dirty="0"/>
           </a:p>
         </p:txBody>
+      </p:sp>
+      <p:sp>
+        <p:nvSpPr>
+          <p:cNvPr id="7" name="Shape 5"/>
+          <p:cNvSpPr/>
+          <p:nvPr/>
+        </p:nvSpPr>
+        <p:spPr>
+          <a:xfrm>
+            <a:off x="822960" y="6035040"/>
+            <a:ext cx="10515600" cy="13716"/>
+          </a:xfrm>
+          <a:prstGeom prst="rect">
+            <a:avLst/>
+          </a:prstGeom>
+          <a:solidFill>
+            <a:srgbClr val="D1D5DB"/>
+          </a:solidFill>
+          <a:ln w="12700">
+            <a:solidFill>
+              <a:srgbClr val="D1D5DB"/>
+            </a:solidFill>
+            <a:prstDash val="solid"/>
+          </a:ln>
+        </p:spPr>
       </p:sp>
     </p:spTree>
   </p:cSld>
@@ -2939,7 +2964,7 @@
     <p:bg>
       <p:bgPr>
         <a:solidFill>
-          <a:srgbClr val="1E2761"/>
+          <a:srgbClr val="FFFFFF"/>
         </a:solidFill>
       </p:bgPr>
     </p:bg>
@@ -2966,17 +2991,17 @@
         <p:spPr>
           <a:xfrm>
             <a:off x="0" y="0"/>
-            <a:ext cx="365760" cy="6858000"/>
+            <a:ext cx="109728" cy="6858000"/>
           </a:xfrm>
           <a:prstGeom prst="rect">
             <a:avLst/>
           </a:prstGeom>
           <a:solidFill>
-            <a:srgbClr val="B85042"/>
+            <a:srgbClr val="6B7280"/>
           </a:solidFill>
           <a:ln w="12700">
             <a:solidFill>
-              <a:srgbClr val="B85042"/>
+              <a:srgbClr val="6B7280"/>
             </a:solidFill>
             <a:prstDash val="solid"/>
           </a:ln>
@@ -3009,7 +3034,7 @@
             <a:r>
               <a:rPr lang="en-US" sz="1600" b="1" spc="400" kern="0" dirty="0">
                 <a:solidFill>
-                  <a:srgbClr val="CADCFC"/>
+                  <a:srgbClr val="6B7280"/>
                 </a:solidFill>
                 <a:latin typeface="Calibri" pitchFamily="34" charset="0"/>
                 <a:ea typeface="Calibri" pitchFamily="34" charset="-122"/>
@@ -3048,7 +3073,7 @@
             <a:r>
               <a:rPr lang="en-US" sz="4400" b="1" dirty="0">
                 <a:solidFill>
-                  <a:srgbClr val="FFFFFF"/>
+                  <a:srgbClr val="1E3A5F"/>
                 </a:solidFill>
                 <a:latin typeface="Calibri" pitchFamily="34" charset="0"/>
                 <a:ea typeface="Calibri" pitchFamily="34" charset="-122"/>
@@ -3087,7 +3112,7 @@
             <a:r>
               <a:rPr lang="en-US" sz="1800" i="1" dirty="0">
                 <a:solidFill>
-                  <a:srgbClr val="CADCFC"/>
+                  <a:srgbClr val="6B7280"/>
                 </a:solidFill>
                 <a:latin typeface="Calibri" pitchFamily="34" charset="0"/>
                 <a:ea typeface="Calibri" pitchFamily="34" charset="-122"/>
@@ -3114,11 +3139,11 @@
             <a:avLst/>
           </a:prstGeom>
           <a:solidFill>
-            <a:srgbClr val="0F1737"/>
+            <a:srgbClr val="F4F5F7"/>
           </a:solidFill>
           <a:ln w="12700">
             <a:solidFill>
-              <a:srgbClr val="B85042"/>
+              <a:srgbClr val="D1D5DB"/>
             </a:solidFill>
             <a:prstDash val="solid"/>
           </a:ln>
@@ -3151,7 +3176,7 @@
             <a:r>
               <a:rPr lang="en-US" sz="1300" b="1" dirty="0">
                 <a:solidFill>
-                  <a:srgbClr val="B85042"/>
+                  <a:srgbClr val="6B7280"/>
                 </a:solidFill>
                 <a:latin typeface="Calibri" pitchFamily="34" charset="0"/>
                 <a:ea typeface="Calibri" pitchFamily="34" charset="-122"/>
@@ -3190,7 +3215,7 @@
             <a:r>
               <a:rPr lang="en-US" sz="1600" b="1" dirty="0">
                 <a:solidFill>
-                  <a:srgbClr val="FFFFFF"/>
+                  <a:srgbClr val="1E3A5F"/>
                 </a:solidFill>
                 <a:latin typeface="Calibri" pitchFamily="34" charset="0"/>
                 <a:ea typeface="Calibri" pitchFamily="34" charset="-122"/>
@@ -3217,11 +3242,11 @@
             <a:avLst/>
           </a:prstGeom>
           <a:solidFill>
-            <a:srgbClr val="0F1737"/>
+            <a:srgbClr val="F4F5F7"/>
           </a:solidFill>
           <a:ln w="12700">
             <a:solidFill>
-              <a:srgbClr val="B85042"/>
+              <a:srgbClr val="D1D5DB"/>
             </a:solidFill>
             <a:prstDash val="solid"/>
           </a:ln>
@@ -3254,7 +3279,7 @@
             <a:r>
               <a:rPr lang="en-US" sz="1300" b="1" dirty="0">
                 <a:solidFill>
-                  <a:srgbClr val="B85042"/>
+                  <a:srgbClr val="6B7280"/>
                 </a:solidFill>
                 <a:latin typeface="Calibri" pitchFamily="34" charset="0"/>
                 <a:ea typeface="Calibri" pitchFamily="34" charset="-122"/>
@@ -3293,7 +3318,7 @@
             <a:r>
               <a:rPr lang="en-US" sz="1600" b="1" dirty="0">
                 <a:solidFill>
-                  <a:srgbClr val="FFFFFF"/>
+                  <a:srgbClr val="1E3A5F"/>
                 </a:solidFill>
                 <a:latin typeface="Calibri" pitchFamily="34" charset="0"/>
                 <a:ea typeface="Calibri" pitchFamily="34" charset="-122"/>
@@ -3320,11 +3345,11 @@
             <a:avLst/>
           </a:prstGeom>
           <a:solidFill>
-            <a:srgbClr val="0F1737"/>
+            <a:srgbClr val="F4F5F7"/>
           </a:solidFill>
           <a:ln w="12700">
             <a:solidFill>
-              <a:srgbClr val="B85042"/>
+              <a:srgbClr val="D1D5DB"/>
             </a:solidFill>
             <a:prstDash val="solid"/>
           </a:ln>
@@ -3357,7 +3382,7 @@
             <a:r>
               <a:rPr lang="en-US" sz="1300" b="1" dirty="0">
                 <a:solidFill>
-                  <a:srgbClr val="B85042"/>
+                  <a:srgbClr val="6B7280"/>
                 </a:solidFill>
                 <a:latin typeface="Calibri" pitchFamily="34" charset="0"/>
                 <a:ea typeface="Calibri" pitchFamily="34" charset="-122"/>
@@ -3396,7 +3421,7 @@
             <a:r>
               <a:rPr lang="en-US" sz="1600" b="1" dirty="0">
                 <a:solidFill>
-                  <a:srgbClr val="FFFFFF"/>
+                  <a:srgbClr val="1E3A5F"/>
                 </a:solidFill>
                 <a:latin typeface="Calibri" pitchFamily="34" charset="0"/>
                 <a:ea typeface="Calibri" pitchFamily="34" charset="-122"/>
@@ -3435,7 +3460,7 @@
             <a:r>
               <a:rPr lang="en-US" sz="1200" i="1" dirty="0">
                 <a:solidFill>
-                  <a:srgbClr val="CADCFC"/>
+                  <a:srgbClr val="6B7280"/>
                 </a:solidFill>
                 <a:latin typeface="Calibri" pitchFamily="34" charset="0"/>
                 <a:ea typeface="Calibri" pitchFamily="34" charset="-122"/>
@@ -3494,11 +3519,11 @@
             <a:avLst/>
           </a:prstGeom>
           <a:solidFill>
-            <a:srgbClr val="B85042"/>
+            <a:srgbClr val="6B7280"/>
           </a:solidFill>
           <a:ln w="12700">
             <a:solidFill>
-              <a:srgbClr val="B85042"/>
+              <a:srgbClr val="6B7280"/>
             </a:solidFill>
             <a:prstDash val="solid"/>
           </a:ln>
@@ -3531,7 +3556,7 @@
             <a:r>
               <a:rPr lang="en-US" sz="1400" b="1" spc="400" kern="0" dirty="0">
                 <a:solidFill>
-                  <a:srgbClr val="B85042"/>
+                  <a:srgbClr val="6B7280"/>
                 </a:solidFill>
                 <a:latin typeface="Calibri" pitchFamily="34" charset="0"/>
                 <a:ea typeface="Calibri" pitchFamily="34" charset="-122"/>
@@ -3570,7 +3595,7 @@
             <a:r>
               <a:rPr lang="en-US" sz="4000" b="1" dirty="0">
                 <a:solidFill>
-                  <a:srgbClr val="1E2761"/>
+                  <a:srgbClr val="1E3A5F"/>
                 </a:solidFill>
                 <a:latin typeface="Calibri" pitchFamily="34" charset="0"/>
                 <a:ea typeface="Calibri" pitchFamily="34" charset="-122"/>
@@ -3597,11 +3622,11 @@
             <a:avLst/>
           </a:prstGeom>
           <a:solidFill>
-            <a:srgbClr val="B85042"/>
+            <a:srgbClr val="6B7280"/>
           </a:solidFill>
           <a:ln w="12700">
             <a:solidFill>
-              <a:srgbClr val="B85042"/>
+              <a:srgbClr val="6B7280"/>
             </a:solidFill>
             <a:prstDash val="solid"/>
           </a:ln>
@@ -3661,7 +3686,7 @@
             <a:avLst/>
           </a:prstGeom>
           <a:solidFill>
-            <a:srgbClr val="F8F6F2"/>
+            <a:srgbClr val="F4F5F7"/>
           </a:solidFill>
           <a:ln w="12700">
             <a:solidFill>
@@ -3698,7 +3723,7 @@
             <a:r>
               <a:rPr lang="en-US" sz="1800" b="1" dirty="0">
                 <a:solidFill>
-                  <a:srgbClr val="1E2761"/>
+                  <a:srgbClr val="1E3A5F"/>
                 </a:solidFill>
                 <a:latin typeface="Calibri" pitchFamily="34" charset="0"/>
                 <a:ea typeface="Calibri" pitchFamily="34" charset="-122"/>
@@ -3737,7 +3762,7 @@
             <a:r>
               <a:rPr lang="en-US" sz="1300" i="1" dirty="0">
                 <a:solidFill>
-                  <a:srgbClr val="B85042"/>
+                  <a:srgbClr val="6B7280"/>
                 </a:solidFill>
                 <a:latin typeface="Calibri" pitchFamily="34" charset="0"/>
                 <a:ea typeface="Calibri" pitchFamily="34" charset="-122"/>
@@ -3803,11 +3828,11 @@
             <a:avLst/>
           </a:prstGeom>
           <a:solidFill>
-            <a:srgbClr val="B85042"/>
+            <a:srgbClr val="6B7280"/>
           </a:solidFill>
           <a:ln w="12700">
             <a:solidFill>
-              <a:srgbClr val="B85042"/>
+              <a:srgbClr val="6B7280"/>
             </a:solidFill>
             <a:prstDash val="solid"/>
           </a:ln>
@@ -3867,7 +3892,7 @@
             <a:avLst/>
           </a:prstGeom>
           <a:solidFill>
-            <a:srgbClr val="F8F6F2"/>
+            <a:srgbClr val="F4F5F7"/>
           </a:solidFill>
           <a:ln w="12700">
             <a:solidFill>
@@ -3904,7 +3929,7 @@
             <a:r>
               <a:rPr lang="en-US" sz="1800" b="1" dirty="0">
                 <a:solidFill>
-                  <a:srgbClr val="1E2761"/>
+                  <a:srgbClr val="1E3A5F"/>
                 </a:solidFill>
                 <a:latin typeface="Calibri" pitchFamily="34" charset="0"/>
                 <a:ea typeface="Calibri" pitchFamily="34" charset="-122"/>
@@ -3943,7 +3968,7 @@
             <a:r>
               <a:rPr lang="en-US" sz="1300" i="1" dirty="0">
                 <a:solidFill>
-                  <a:srgbClr val="B85042"/>
+                  <a:srgbClr val="6B7280"/>
                 </a:solidFill>
                 <a:latin typeface="Calibri" pitchFamily="34" charset="0"/>
                 <a:ea typeface="Calibri" pitchFamily="34" charset="-122"/>
@@ -4009,11 +4034,11 @@
             <a:avLst/>
           </a:prstGeom>
           <a:solidFill>
-            <a:srgbClr val="B85042"/>
+            <a:srgbClr val="6B7280"/>
           </a:solidFill>
           <a:ln w="12700">
             <a:solidFill>
-              <a:srgbClr val="B85042"/>
+              <a:srgbClr val="6B7280"/>
             </a:solidFill>
             <a:prstDash val="solid"/>
           </a:ln>
@@ -4073,7 +4098,7 @@
             <a:avLst/>
           </a:prstGeom>
           <a:solidFill>
-            <a:srgbClr val="F8F6F2"/>
+            <a:srgbClr val="F4F5F7"/>
           </a:solidFill>
           <a:ln w="12700">
             <a:solidFill>
@@ -4110,7 +4135,7 @@
             <a:r>
               <a:rPr lang="en-US" sz="1800" b="1" dirty="0">
                 <a:solidFill>
-                  <a:srgbClr val="1E2761"/>
+                  <a:srgbClr val="1E3A5F"/>
                 </a:solidFill>
                 <a:latin typeface="Calibri" pitchFamily="34" charset="0"/>
                 <a:ea typeface="Calibri" pitchFamily="34" charset="-122"/>
@@ -4149,7 +4174,7 @@
             <a:r>
               <a:rPr lang="en-US" sz="1300" i="1" dirty="0">
                 <a:solidFill>
-                  <a:srgbClr val="B85042"/>
+                  <a:srgbClr val="6B7280"/>
                 </a:solidFill>
                 <a:latin typeface="Calibri" pitchFamily="34" charset="0"/>
                 <a:ea typeface="Calibri" pitchFamily="34" charset="-122"/>
@@ -4227,7 +4252,7 @@
             <a:r>
               <a:rPr lang="en-US" sz="1000" dirty="0">
                 <a:solidFill>
-                  <a:srgbClr val="888888"/>
+                  <a:srgbClr val="6B7280"/>
                 </a:solidFill>
                 <a:latin typeface="Calibri" pitchFamily="34" charset="0"/>
                 <a:ea typeface="Calibri" pitchFamily="34" charset="-122"/>
@@ -4253,7 +4278,7 @@
     <p:bg>
       <p:bgPr>
         <a:solidFill>
-          <a:srgbClr val="1E2761"/>
+          <a:srgbClr val="FFFFFF"/>
         </a:solidFill>
       </p:bgPr>
     </p:bg>
@@ -4280,17 +4305,17 @@
         <p:spPr>
           <a:xfrm>
             <a:off x="0" y="0"/>
-            <a:ext cx="365760" cy="6858000"/>
+            <a:ext cx="109728" cy="6858000"/>
           </a:xfrm>
           <a:prstGeom prst="rect">
             <a:avLst/>
           </a:prstGeom>
           <a:solidFill>
-            <a:srgbClr val="B85042"/>
+            <a:srgbClr val="6B7280"/>
           </a:solidFill>
           <a:ln w="12700">
             <a:solidFill>
-              <a:srgbClr val="B85042"/>
+              <a:srgbClr val="6B7280"/>
             </a:solidFill>
             <a:prstDash val="solid"/>
           </a:ln>
@@ -4323,7 +4348,7 @@
             <a:r>
               <a:rPr lang="en-US" sz="1600" b="1" spc="400" kern="0" dirty="0">
                 <a:solidFill>
-                  <a:srgbClr val="CADCFC"/>
+                  <a:srgbClr val="6B7280"/>
                 </a:solidFill>
                 <a:latin typeface="Calibri" pitchFamily="34" charset="0"/>
                 <a:ea typeface="Calibri" pitchFamily="34" charset="-122"/>
@@ -4362,7 +4387,7 @@
             <a:r>
               <a:rPr lang="en-US" sz="4400" b="1" dirty="0">
                 <a:solidFill>
-                  <a:srgbClr val="FFFFFF"/>
+                  <a:srgbClr val="1E3A5F"/>
                 </a:solidFill>
                 <a:latin typeface="Calibri" pitchFamily="34" charset="0"/>
                 <a:ea typeface="Calibri" pitchFamily="34" charset="-122"/>
@@ -4401,7 +4426,7 @@
             <a:r>
               <a:rPr lang="en-US" sz="1800" i="1" dirty="0">
                 <a:solidFill>
-                  <a:srgbClr val="CADCFC"/>
+                  <a:srgbClr val="6B7280"/>
                 </a:solidFill>
                 <a:latin typeface="Calibri" pitchFamily="34" charset="0"/>
                 <a:ea typeface="Calibri" pitchFamily="34" charset="-122"/>
@@ -4428,11 +4453,11 @@
             <a:avLst/>
           </a:prstGeom>
           <a:solidFill>
-            <a:srgbClr val="0F1737"/>
+            <a:srgbClr val="F4F5F7"/>
           </a:solidFill>
           <a:ln w="12700">
             <a:solidFill>
-              <a:srgbClr val="B85042"/>
+              <a:srgbClr val="D1D5DB"/>
             </a:solidFill>
             <a:prstDash val="solid"/>
           </a:ln>
@@ -4465,7 +4490,7 @@
             <a:r>
               <a:rPr lang="en-US" sz="1300" b="1" dirty="0">
                 <a:solidFill>
-                  <a:srgbClr val="B85042"/>
+                  <a:srgbClr val="6B7280"/>
                 </a:solidFill>
                 <a:latin typeface="Calibri" pitchFamily="34" charset="0"/>
                 <a:ea typeface="Calibri" pitchFamily="34" charset="-122"/>
@@ -4504,7 +4529,7 @@
             <a:r>
               <a:rPr lang="en-US" sz="1600" b="1" dirty="0">
                 <a:solidFill>
-                  <a:srgbClr val="FFFFFF"/>
+                  <a:srgbClr val="1E3A5F"/>
                 </a:solidFill>
                 <a:latin typeface="Calibri" pitchFamily="34" charset="0"/>
                 <a:ea typeface="Calibri" pitchFamily="34" charset="-122"/>
@@ -4531,11 +4556,11 @@
             <a:avLst/>
           </a:prstGeom>
           <a:solidFill>
-            <a:srgbClr val="0F1737"/>
+            <a:srgbClr val="F4F5F7"/>
           </a:solidFill>
           <a:ln w="12700">
             <a:solidFill>
-              <a:srgbClr val="B85042"/>
+              <a:srgbClr val="D1D5DB"/>
             </a:solidFill>
             <a:prstDash val="solid"/>
           </a:ln>
@@ -4568,7 +4593,7 @@
             <a:r>
               <a:rPr lang="en-US" sz="1300" b="1" dirty="0">
                 <a:solidFill>
-                  <a:srgbClr val="B85042"/>
+                  <a:srgbClr val="6B7280"/>
                 </a:solidFill>
                 <a:latin typeface="Calibri" pitchFamily="34" charset="0"/>
                 <a:ea typeface="Calibri" pitchFamily="34" charset="-122"/>
@@ -4607,7 +4632,7 @@
             <a:r>
               <a:rPr lang="en-US" sz="1600" b="1" dirty="0">
                 <a:solidFill>
-                  <a:srgbClr val="FFFFFF"/>
+                  <a:srgbClr val="1E3A5F"/>
                 </a:solidFill>
                 <a:latin typeface="Calibri" pitchFamily="34" charset="0"/>
                 <a:ea typeface="Calibri" pitchFamily="34" charset="-122"/>
@@ -4634,11 +4659,11 @@
             <a:avLst/>
           </a:prstGeom>
           <a:solidFill>
-            <a:srgbClr val="0F1737"/>
+            <a:srgbClr val="F4F5F7"/>
           </a:solidFill>
           <a:ln w="12700">
             <a:solidFill>
-              <a:srgbClr val="B85042"/>
+              <a:srgbClr val="D1D5DB"/>
             </a:solidFill>
             <a:prstDash val="solid"/>
           </a:ln>
@@ -4671,7 +4696,7 @@
             <a:r>
               <a:rPr lang="en-US" sz="1300" b="1" dirty="0">
                 <a:solidFill>
-                  <a:srgbClr val="B85042"/>
+                  <a:srgbClr val="6B7280"/>
                 </a:solidFill>
                 <a:latin typeface="Calibri" pitchFamily="34" charset="0"/>
                 <a:ea typeface="Calibri" pitchFamily="34" charset="-122"/>
@@ -4710,7 +4735,7 @@
             <a:r>
               <a:rPr lang="en-US" sz="1600" b="1" dirty="0">
                 <a:solidFill>
-                  <a:srgbClr val="FFFFFF"/>
+                  <a:srgbClr val="1E3A5F"/>
                 </a:solidFill>
                 <a:latin typeface="Calibri" pitchFamily="34" charset="0"/>
                 <a:ea typeface="Calibri" pitchFamily="34" charset="-122"/>
@@ -4749,7 +4774,7 @@
             <a:r>
               <a:rPr lang="en-US" sz="1200" i="1" dirty="0">
                 <a:solidFill>
-                  <a:srgbClr val="CADCFC"/>
+                  <a:srgbClr val="6B7280"/>
                 </a:solidFill>
                 <a:latin typeface="Calibri" pitchFamily="34" charset="0"/>
                 <a:ea typeface="Calibri" pitchFamily="34" charset="-122"/>
@@ -4808,11 +4833,11 @@
             <a:avLst/>
           </a:prstGeom>
           <a:solidFill>
-            <a:srgbClr val="B85042"/>
+            <a:srgbClr val="6B7280"/>
           </a:solidFill>
           <a:ln w="12700">
             <a:solidFill>
-              <a:srgbClr val="B85042"/>
+              <a:srgbClr val="6B7280"/>
             </a:solidFill>
             <a:prstDash val="solid"/>
           </a:ln>
@@ -4845,7 +4870,7 @@
             <a:r>
               <a:rPr lang="en-US" sz="1400" b="1" spc="400" kern="0" dirty="0">
                 <a:solidFill>
-                  <a:srgbClr val="B85042"/>
+                  <a:srgbClr val="6B7280"/>
                 </a:solidFill>
                 <a:latin typeface="Calibri" pitchFamily="34" charset="0"/>
                 <a:ea typeface="Calibri" pitchFamily="34" charset="-122"/>
@@ -4884,7 +4909,7 @@
             <a:r>
               <a:rPr lang="en-US" sz="4000" b="1" dirty="0">
                 <a:solidFill>
-                  <a:srgbClr val="1E2761"/>
+                  <a:srgbClr val="1E3A5F"/>
                 </a:solidFill>
                 <a:latin typeface="Calibri" pitchFamily="34" charset="0"/>
                 <a:ea typeface="Calibri" pitchFamily="34" charset="-122"/>
@@ -4911,11 +4936,11 @@
             <a:avLst/>
           </a:prstGeom>
           <a:solidFill>
-            <a:srgbClr val="B85042"/>
+            <a:srgbClr val="6B7280"/>
           </a:solidFill>
           <a:ln w="12700">
             <a:solidFill>
-              <a:srgbClr val="B85042"/>
+              <a:srgbClr val="6B7280"/>
             </a:solidFill>
             <a:prstDash val="solid"/>
           </a:ln>
@@ -4975,7 +5000,7 @@
             <a:avLst/>
           </a:prstGeom>
           <a:solidFill>
-            <a:srgbClr val="F8F6F2"/>
+            <a:srgbClr val="F4F5F7"/>
           </a:solidFill>
           <a:ln w="12700">
             <a:solidFill>
@@ -5012,7 +5037,7 @@
             <a:r>
               <a:rPr lang="en-US" sz="1800" b="1" dirty="0">
                 <a:solidFill>
-                  <a:srgbClr val="1E2761"/>
+                  <a:srgbClr val="1E3A5F"/>
                 </a:solidFill>
                 <a:latin typeface="Calibri" pitchFamily="34" charset="0"/>
                 <a:ea typeface="Calibri" pitchFamily="34" charset="-122"/>
@@ -5051,7 +5076,7 @@
             <a:r>
               <a:rPr lang="en-US" sz="1300" i="1" dirty="0">
                 <a:solidFill>
-                  <a:srgbClr val="B85042"/>
+                  <a:srgbClr val="6B7280"/>
                 </a:solidFill>
                 <a:latin typeface="Calibri" pitchFamily="34" charset="0"/>
                 <a:ea typeface="Calibri" pitchFamily="34" charset="-122"/>
@@ -5117,11 +5142,11 @@
             <a:avLst/>
           </a:prstGeom>
           <a:solidFill>
-            <a:srgbClr val="B85042"/>
+            <a:srgbClr val="6B7280"/>
           </a:solidFill>
           <a:ln w="12700">
             <a:solidFill>
-              <a:srgbClr val="B85042"/>
+              <a:srgbClr val="6B7280"/>
             </a:solidFill>
             <a:prstDash val="solid"/>
           </a:ln>
@@ -5181,7 +5206,7 @@
             <a:avLst/>
           </a:prstGeom>
           <a:solidFill>
-            <a:srgbClr val="F8F6F2"/>
+            <a:srgbClr val="F4F5F7"/>
           </a:solidFill>
           <a:ln w="12700">
             <a:solidFill>
@@ -5218,7 +5243,7 @@
             <a:r>
               <a:rPr lang="en-US" sz="1800" b="1" dirty="0">
                 <a:solidFill>
-                  <a:srgbClr val="1E2761"/>
+                  <a:srgbClr val="1E3A5F"/>
                 </a:solidFill>
                 <a:latin typeface="Calibri" pitchFamily="34" charset="0"/>
                 <a:ea typeface="Calibri" pitchFamily="34" charset="-122"/>
@@ -5257,7 +5282,7 @@
             <a:r>
               <a:rPr lang="en-US" sz="1300" i="1" dirty="0">
                 <a:solidFill>
-                  <a:srgbClr val="B85042"/>
+                  <a:srgbClr val="6B7280"/>
                 </a:solidFill>
                 <a:latin typeface="Calibri" pitchFamily="34" charset="0"/>
                 <a:ea typeface="Calibri" pitchFamily="34" charset="-122"/>
@@ -5323,11 +5348,11 @@
             <a:avLst/>
           </a:prstGeom>
           <a:solidFill>
-            <a:srgbClr val="B85042"/>
+            <a:srgbClr val="6B7280"/>
           </a:solidFill>
           <a:ln w="12700">
             <a:solidFill>
-              <a:srgbClr val="B85042"/>
+              <a:srgbClr val="6B7280"/>
             </a:solidFill>
             <a:prstDash val="solid"/>
           </a:ln>
@@ -5387,7 +5412,7 @@
             <a:avLst/>
           </a:prstGeom>
           <a:solidFill>
-            <a:srgbClr val="F8F6F2"/>
+            <a:srgbClr val="F4F5F7"/>
           </a:solidFill>
           <a:ln w="12700">
             <a:solidFill>
@@ -5424,7 +5449,7 @@
             <a:r>
               <a:rPr lang="en-US" sz="1800" b="1" dirty="0">
                 <a:solidFill>
-                  <a:srgbClr val="1E2761"/>
+                  <a:srgbClr val="1E3A5F"/>
                 </a:solidFill>
                 <a:latin typeface="Calibri" pitchFamily="34" charset="0"/>
                 <a:ea typeface="Calibri" pitchFamily="34" charset="-122"/>
@@ -5463,7 +5488,7 @@
             <a:r>
               <a:rPr lang="en-US" sz="1300" i="1" dirty="0">
                 <a:solidFill>
-                  <a:srgbClr val="B85042"/>
+                  <a:srgbClr val="6B7280"/>
                 </a:solidFill>
                 <a:latin typeface="Calibri" pitchFamily="34" charset="0"/>
                 <a:ea typeface="Calibri" pitchFamily="34" charset="-122"/>
@@ -5541,7 +5566,7 @@
             <a:r>
               <a:rPr lang="en-US" sz="1000" dirty="0">
                 <a:solidFill>
-                  <a:srgbClr val="888888"/>
+                  <a:srgbClr val="6B7280"/>
                 </a:solidFill>
                 <a:latin typeface="Calibri" pitchFamily="34" charset="0"/>
                 <a:ea typeface="Calibri" pitchFamily="34" charset="-122"/>
@@ -5567,7 +5592,7 @@
     <p:bg>
       <p:bgPr>
         <a:solidFill>
-          <a:srgbClr val="1E2761"/>
+          <a:srgbClr val="FFFFFF"/>
         </a:solidFill>
       </p:bgPr>
     </p:bg>
@@ -5594,17 +5619,17 @@
         <p:spPr>
           <a:xfrm>
             <a:off x="0" y="0"/>
-            <a:ext cx="365760" cy="6858000"/>
+            <a:ext cx="109728" cy="6858000"/>
           </a:xfrm>
           <a:prstGeom prst="rect">
             <a:avLst/>
           </a:prstGeom>
           <a:solidFill>
-            <a:srgbClr val="B85042"/>
+            <a:srgbClr val="6B7280"/>
           </a:solidFill>
           <a:ln w="12700">
             <a:solidFill>
-              <a:srgbClr val="B85042"/>
+              <a:srgbClr val="6B7280"/>
             </a:solidFill>
             <a:prstDash val="solid"/>
           </a:ln>
@@ -5637,7 +5662,7 @@
             <a:r>
               <a:rPr lang="en-US" sz="1600" b="1" spc="400" kern="0" dirty="0">
                 <a:solidFill>
-                  <a:srgbClr val="CADCFC"/>
+                  <a:srgbClr val="6B7280"/>
                 </a:solidFill>
                 <a:latin typeface="Calibri" pitchFamily="34" charset="0"/>
                 <a:ea typeface="Calibri" pitchFamily="34" charset="-122"/>
@@ -5676,7 +5701,7 @@
             <a:r>
               <a:rPr lang="en-US" sz="4400" b="1" dirty="0">
                 <a:solidFill>
-                  <a:srgbClr val="FFFFFF"/>
+                  <a:srgbClr val="1E3A5F"/>
                 </a:solidFill>
                 <a:latin typeface="Calibri" pitchFamily="34" charset="0"/>
                 <a:ea typeface="Calibri" pitchFamily="34" charset="-122"/>
@@ -5715,7 +5740,7 @@
             <a:r>
               <a:rPr lang="en-US" sz="1800" i="1" dirty="0">
                 <a:solidFill>
-                  <a:srgbClr val="CADCFC"/>
+                  <a:srgbClr val="6B7280"/>
                 </a:solidFill>
                 <a:latin typeface="Calibri" pitchFamily="34" charset="0"/>
                 <a:ea typeface="Calibri" pitchFamily="34" charset="-122"/>
@@ -5742,11 +5767,11 @@
             <a:avLst/>
           </a:prstGeom>
           <a:solidFill>
-            <a:srgbClr val="0F1737"/>
+            <a:srgbClr val="F4F5F7"/>
           </a:solidFill>
           <a:ln w="12700">
             <a:solidFill>
-              <a:srgbClr val="B85042"/>
+              <a:srgbClr val="D1D5DB"/>
             </a:solidFill>
             <a:prstDash val="solid"/>
           </a:ln>
@@ -5779,7 +5804,7 @@
             <a:r>
               <a:rPr lang="en-US" sz="1300" b="1" dirty="0">
                 <a:solidFill>
-                  <a:srgbClr val="B85042"/>
+                  <a:srgbClr val="6B7280"/>
                 </a:solidFill>
                 <a:latin typeface="Calibri" pitchFamily="34" charset="0"/>
                 <a:ea typeface="Calibri" pitchFamily="34" charset="-122"/>
@@ -5818,7 +5843,7 @@
             <a:r>
               <a:rPr lang="en-US" sz="1600" b="1" dirty="0">
                 <a:solidFill>
-                  <a:srgbClr val="FFFFFF"/>
+                  <a:srgbClr val="1E3A5F"/>
                 </a:solidFill>
                 <a:latin typeface="Calibri" pitchFamily="34" charset="0"/>
                 <a:ea typeface="Calibri" pitchFamily="34" charset="-122"/>
@@ -5845,11 +5870,11 @@
             <a:avLst/>
           </a:prstGeom>
           <a:solidFill>
-            <a:srgbClr val="0F1737"/>
+            <a:srgbClr val="F4F5F7"/>
           </a:solidFill>
           <a:ln w="12700">
             <a:solidFill>
-              <a:srgbClr val="B85042"/>
+              <a:srgbClr val="D1D5DB"/>
             </a:solidFill>
             <a:prstDash val="solid"/>
           </a:ln>
@@ -5882,7 +5907,7 @@
             <a:r>
               <a:rPr lang="en-US" sz="1300" b="1" dirty="0">
                 <a:solidFill>
-                  <a:srgbClr val="B85042"/>
+                  <a:srgbClr val="6B7280"/>
                 </a:solidFill>
                 <a:latin typeface="Calibri" pitchFamily="34" charset="0"/>
                 <a:ea typeface="Calibri" pitchFamily="34" charset="-122"/>
@@ -5921,7 +5946,7 @@
             <a:r>
               <a:rPr lang="en-US" sz="1600" b="1" dirty="0">
                 <a:solidFill>
-                  <a:srgbClr val="FFFFFF"/>
+                  <a:srgbClr val="1E3A5F"/>
                 </a:solidFill>
                 <a:latin typeface="Calibri" pitchFamily="34" charset="0"/>
                 <a:ea typeface="Calibri" pitchFamily="34" charset="-122"/>
@@ -5948,11 +5973,11 @@
             <a:avLst/>
           </a:prstGeom>
           <a:solidFill>
-            <a:srgbClr val="0F1737"/>
+            <a:srgbClr val="F4F5F7"/>
           </a:solidFill>
           <a:ln w="12700">
             <a:solidFill>
-              <a:srgbClr val="B85042"/>
+              <a:srgbClr val="D1D5DB"/>
             </a:solidFill>
             <a:prstDash val="solid"/>
           </a:ln>
@@ -5985,7 +6010,7 @@
             <a:r>
               <a:rPr lang="en-US" sz="1300" b="1" dirty="0">
                 <a:solidFill>
-                  <a:srgbClr val="B85042"/>
+                  <a:srgbClr val="6B7280"/>
                 </a:solidFill>
                 <a:latin typeface="Calibri" pitchFamily="34" charset="0"/>
                 <a:ea typeface="Calibri" pitchFamily="34" charset="-122"/>
@@ -6024,7 +6049,7 @@
             <a:r>
               <a:rPr lang="en-US" sz="1600" b="1" dirty="0">
                 <a:solidFill>
-                  <a:srgbClr val="FFFFFF"/>
+                  <a:srgbClr val="1E3A5F"/>
                 </a:solidFill>
                 <a:latin typeface="Calibri" pitchFamily="34" charset="0"/>
                 <a:ea typeface="Calibri" pitchFamily="34" charset="-122"/>
@@ -6063,7 +6088,7 @@
             <a:r>
               <a:rPr lang="en-US" sz="1200" i="1" dirty="0">
                 <a:solidFill>
-                  <a:srgbClr val="CADCFC"/>
+                  <a:srgbClr val="6B7280"/>
                 </a:solidFill>
                 <a:latin typeface="Calibri" pitchFamily="34" charset="0"/>
                 <a:ea typeface="Calibri" pitchFamily="34" charset="-122"/>
@@ -6122,11 +6147,11 @@
             <a:avLst/>
           </a:prstGeom>
           <a:solidFill>
-            <a:srgbClr val="B85042"/>
+            <a:srgbClr val="6B7280"/>
           </a:solidFill>
           <a:ln w="12700">
             <a:solidFill>
-              <a:srgbClr val="B85042"/>
+              <a:srgbClr val="6B7280"/>
             </a:solidFill>
             <a:prstDash val="solid"/>
           </a:ln>
@@ -6159,7 +6184,7 @@
             <a:r>
               <a:rPr lang="en-US" sz="1400" b="1" spc="400" kern="0" dirty="0">
                 <a:solidFill>
-                  <a:srgbClr val="B85042"/>
+                  <a:srgbClr val="6B7280"/>
                 </a:solidFill>
                 <a:latin typeface="Calibri" pitchFamily="34" charset="0"/>
                 <a:ea typeface="Calibri" pitchFamily="34" charset="-122"/>
@@ -6198,7 +6223,7 @@
             <a:r>
               <a:rPr lang="en-US" sz="4000" b="1" dirty="0">
                 <a:solidFill>
-                  <a:srgbClr val="1E2761"/>
+                  <a:srgbClr val="1E3A5F"/>
                 </a:solidFill>
                 <a:latin typeface="Calibri" pitchFamily="34" charset="0"/>
                 <a:ea typeface="Calibri" pitchFamily="34" charset="-122"/>
@@ -6225,11 +6250,11 @@
             <a:avLst/>
           </a:prstGeom>
           <a:solidFill>
-            <a:srgbClr val="B85042"/>
+            <a:srgbClr val="6B7280"/>
           </a:solidFill>
           <a:ln w="12700">
             <a:solidFill>
-              <a:srgbClr val="B85042"/>
+              <a:srgbClr val="6B7280"/>
             </a:solidFill>
             <a:prstDash val="solid"/>
           </a:ln>
@@ -6289,7 +6314,7 @@
             <a:avLst/>
           </a:prstGeom>
           <a:solidFill>
-            <a:srgbClr val="F8F6F2"/>
+            <a:srgbClr val="F4F5F7"/>
           </a:solidFill>
           <a:ln w="12700">
             <a:solidFill>
@@ -6326,7 +6351,7 @@
             <a:r>
               <a:rPr lang="en-US" sz="1800" b="1" dirty="0">
                 <a:solidFill>
-                  <a:srgbClr val="1E2761"/>
+                  <a:srgbClr val="1E3A5F"/>
                 </a:solidFill>
                 <a:latin typeface="Calibri" pitchFamily="34" charset="0"/>
                 <a:ea typeface="Calibri" pitchFamily="34" charset="-122"/>
@@ -6365,7 +6390,7 @@
             <a:r>
               <a:rPr lang="en-US" sz="1300" i="1" dirty="0">
                 <a:solidFill>
-                  <a:srgbClr val="B85042"/>
+                  <a:srgbClr val="6B7280"/>
                 </a:solidFill>
                 <a:latin typeface="Calibri" pitchFamily="34" charset="0"/>
                 <a:ea typeface="Calibri" pitchFamily="34" charset="-122"/>
@@ -6431,11 +6456,11 @@
             <a:avLst/>
           </a:prstGeom>
           <a:solidFill>
-            <a:srgbClr val="B85042"/>
+            <a:srgbClr val="6B7280"/>
           </a:solidFill>
           <a:ln w="12700">
             <a:solidFill>
-              <a:srgbClr val="B85042"/>
+              <a:srgbClr val="6B7280"/>
             </a:solidFill>
             <a:prstDash val="solid"/>
           </a:ln>
@@ -6495,7 +6520,7 @@
             <a:avLst/>
           </a:prstGeom>
           <a:solidFill>
-            <a:srgbClr val="F8F6F2"/>
+            <a:srgbClr val="F4F5F7"/>
           </a:solidFill>
           <a:ln w="12700">
             <a:solidFill>
@@ -6532,7 +6557,7 @@
             <a:r>
               <a:rPr lang="en-US" sz="1800" b="1" dirty="0">
                 <a:solidFill>
-                  <a:srgbClr val="1E2761"/>
+                  <a:srgbClr val="1E3A5F"/>
                 </a:solidFill>
                 <a:latin typeface="Calibri" pitchFamily="34" charset="0"/>
                 <a:ea typeface="Calibri" pitchFamily="34" charset="-122"/>
@@ -6571,7 +6596,7 @@
             <a:r>
               <a:rPr lang="en-US" sz="1300" i="1" dirty="0">
                 <a:solidFill>
-                  <a:srgbClr val="B85042"/>
+                  <a:srgbClr val="6B7280"/>
                 </a:solidFill>
                 <a:latin typeface="Calibri" pitchFamily="34" charset="0"/>
                 <a:ea typeface="Calibri" pitchFamily="34" charset="-122"/>
@@ -6637,11 +6662,11 @@
             <a:avLst/>
           </a:prstGeom>
           <a:solidFill>
-            <a:srgbClr val="B85042"/>
+            <a:srgbClr val="6B7280"/>
           </a:solidFill>
           <a:ln w="12700">
             <a:solidFill>
-              <a:srgbClr val="B85042"/>
+              <a:srgbClr val="6B7280"/>
             </a:solidFill>
             <a:prstDash val="solid"/>
           </a:ln>
@@ -6701,7 +6726,7 @@
             <a:avLst/>
           </a:prstGeom>
           <a:solidFill>
-            <a:srgbClr val="F8F6F2"/>
+            <a:srgbClr val="F4F5F7"/>
           </a:solidFill>
           <a:ln w="12700">
             <a:solidFill>
@@ -6738,7 +6763,7 @@
             <a:r>
               <a:rPr lang="en-US" sz="1800" b="1" dirty="0">
                 <a:solidFill>
-                  <a:srgbClr val="1E2761"/>
+                  <a:srgbClr val="1E3A5F"/>
                 </a:solidFill>
                 <a:latin typeface="Calibri" pitchFamily="34" charset="0"/>
                 <a:ea typeface="Calibri" pitchFamily="34" charset="-122"/>
@@ -6777,7 +6802,7 @@
             <a:r>
               <a:rPr lang="en-US" sz="1300" i="1" dirty="0">
                 <a:solidFill>
-                  <a:srgbClr val="B85042"/>
+                  <a:srgbClr val="6B7280"/>
                 </a:solidFill>
                 <a:latin typeface="Calibri" pitchFamily="34" charset="0"/>
                 <a:ea typeface="Calibri" pitchFamily="34" charset="-122"/>
@@ -6855,7 +6880,7 @@
             <a:r>
               <a:rPr lang="en-US" sz="1000" dirty="0">
                 <a:solidFill>
-                  <a:srgbClr val="888888"/>
+                  <a:srgbClr val="6B7280"/>
                 </a:solidFill>
                 <a:latin typeface="Calibri" pitchFamily="34" charset="0"/>
                 <a:ea typeface="Calibri" pitchFamily="34" charset="-122"/>
@@ -6914,11 +6939,11 @@
             <a:avLst/>
           </a:prstGeom>
           <a:solidFill>
-            <a:srgbClr val="B85042"/>
+            <a:srgbClr val="6B7280"/>
           </a:solidFill>
           <a:ln w="12700">
             <a:solidFill>
-              <a:srgbClr val="B85042"/>
+              <a:srgbClr val="6B7280"/>
             </a:solidFill>
             <a:prstDash val="solid"/>
           </a:ln>
@@ -6951,7 +6976,7 @@
             <a:r>
               <a:rPr lang="en-US" sz="1400" b="1" spc="400" kern="0" dirty="0">
                 <a:solidFill>
-                  <a:srgbClr val="B85042"/>
+                  <a:srgbClr val="6B7280"/>
                 </a:solidFill>
                 <a:latin typeface="Calibri" pitchFamily="34" charset="0"/>
                 <a:ea typeface="Calibri" pitchFamily="34" charset="-122"/>
@@ -6990,7 +7015,7 @@
             <a:r>
               <a:rPr lang="en-US" sz="4000" b="1" dirty="0">
                 <a:solidFill>
-                  <a:srgbClr val="1E2761"/>
+                  <a:srgbClr val="1E3A5F"/>
                 </a:solidFill>
                 <a:latin typeface="Calibri" pitchFamily="34" charset="0"/>
                 <a:ea typeface="Calibri" pitchFamily="34" charset="-122"/>
@@ -7017,7 +7042,7 @@
             <a:avLst/>
           </a:prstGeom>
           <a:solidFill>
-            <a:srgbClr val="F8F6F2"/>
+            <a:srgbClr val="F4F5F7"/>
           </a:solidFill>
           <a:ln w="12700">
             <a:solidFill>
@@ -7054,7 +7079,7 @@
             <a:r>
               <a:rPr lang="en-US" sz="2800" b="1" dirty="0">
                 <a:solidFill>
-                  <a:srgbClr val="B85042"/>
+                  <a:srgbClr val="6B7280"/>
                 </a:solidFill>
                 <a:latin typeface="Calibri" pitchFamily="34" charset="0"/>
                 <a:ea typeface="Calibri" pitchFamily="34" charset="-122"/>
@@ -7276,11 +7301,11 @@
             <a:avLst/>
           </a:prstGeom>
           <a:solidFill>
-            <a:srgbClr val="1E2761"/>
+            <a:srgbClr val="1E3A5F"/>
           </a:solidFill>
           <a:ln w="12700">
             <a:solidFill>
-              <a:srgbClr val="1E2761"/>
+              <a:srgbClr val="1E3A5F"/>
             </a:solidFill>
             <a:prstDash val="solid"/>
           </a:ln>
@@ -7313,7 +7338,7 @@
             <a:r>
               <a:rPr lang="en-US" sz="1200" b="1" spc="400" kern="0" dirty="0">
                 <a:solidFill>
-                  <a:srgbClr val="CADCFC"/>
+                  <a:srgbClr val="9CA3AF"/>
                 </a:solidFill>
                 <a:latin typeface="Calibri" pitchFamily="34" charset="0"/>
                 <a:ea typeface="Calibri" pitchFamily="34" charset="-122"/>
@@ -7352,7 +7377,7 @@
             <a:r>
               <a:rPr lang="en-US" sz="1400" dirty="0">
                 <a:solidFill>
-                  <a:srgbClr val="CADCFC"/>
+                  <a:srgbClr val="9CA3AF"/>
                 </a:solidFill>
                 <a:latin typeface="Calibri" pitchFamily="34" charset="0"/>
                 <a:ea typeface="Calibri" pitchFamily="34" charset="-122"/>
@@ -7430,7 +7455,7 @@
             <a:r>
               <a:rPr lang="en-US" sz="1400" dirty="0">
                 <a:solidFill>
-                  <a:srgbClr val="B85042"/>
+                  <a:srgbClr val="6B7280"/>
                 </a:solidFill>
                 <a:latin typeface="Calibri" pitchFamily="34" charset="0"/>
                 <a:ea typeface="Calibri" pitchFamily="34" charset="-122"/>
@@ -7469,7 +7494,7 @@
             <a:r>
               <a:rPr lang="en-US" sz="1000" dirty="0">
                 <a:solidFill>
-                  <a:srgbClr val="888888"/>
+                  <a:srgbClr val="6B7280"/>
                 </a:solidFill>
                 <a:latin typeface="Calibri" pitchFamily="34" charset="0"/>
                 <a:ea typeface="Calibri" pitchFamily="34" charset="-122"/>
@@ -7528,11 +7553,11 @@
             <a:avLst/>
           </a:prstGeom>
           <a:solidFill>
-            <a:srgbClr val="B85042"/>
+            <a:srgbClr val="6B7280"/>
           </a:solidFill>
           <a:ln w="12700">
             <a:solidFill>
-              <a:srgbClr val="B85042"/>
+              <a:srgbClr val="6B7280"/>
             </a:solidFill>
             <a:prstDash val="solid"/>
           </a:ln>
@@ -7565,7 +7590,7 @@
             <a:r>
               <a:rPr lang="en-US" sz="1400" b="1" spc="400" kern="0" dirty="0">
                 <a:solidFill>
-                  <a:srgbClr val="B85042"/>
+                  <a:srgbClr val="6B7280"/>
                 </a:solidFill>
                 <a:latin typeface="Calibri" pitchFamily="34" charset="0"/>
                 <a:ea typeface="Calibri" pitchFamily="34" charset="-122"/>
@@ -7604,7 +7629,7 @@
             <a:r>
               <a:rPr lang="en-US" sz="4000" b="1" dirty="0">
                 <a:solidFill>
-                  <a:srgbClr val="1E2761"/>
+                  <a:srgbClr val="1E3A5F"/>
                 </a:solidFill>
                 <a:latin typeface="Calibri" pitchFamily="34" charset="0"/>
                 <a:ea typeface="Calibri" pitchFamily="34" charset="-122"/>
@@ -7631,11 +7656,11 @@
             <a:avLst/>
           </a:prstGeom>
           <a:solidFill>
-            <a:srgbClr val="B85042"/>
+            <a:srgbClr val="6B7280"/>
           </a:solidFill>
           <a:ln w="12700">
             <a:solidFill>
-              <a:srgbClr val="B85042"/>
+              <a:srgbClr val="6B7280"/>
             </a:solidFill>
             <a:prstDash val="solid"/>
           </a:ln>
@@ -7734,11 +7759,11 @@
             <a:avLst/>
           </a:prstGeom>
           <a:solidFill>
-            <a:srgbClr val="1E2761"/>
+            <a:srgbClr val="1E3A5F"/>
           </a:solidFill>
           <a:ln w="12700">
             <a:solidFill>
-              <a:srgbClr val="1E2761"/>
+              <a:srgbClr val="1E3A5F"/>
             </a:solidFill>
             <a:prstDash val="solid"/>
           </a:ln>
@@ -7837,11 +7862,11 @@
             <a:avLst/>
           </a:prstGeom>
           <a:solidFill>
-            <a:srgbClr val="84B59F"/>
+            <a:srgbClr val="6B7280"/>
           </a:solidFill>
           <a:ln w="12700">
             <a:solidFill>
-              <a:srgbClr val="84B59F"/>
+              <a:srgbClr val="6B7280"/>
             </a:solidFill>
             <a:prstDash val="solid"/>
           </a:ln>
@@ -7940,11 +7965,11 @@
             <a:avLst/>
           </a:prstGeom>
           <a:solidFill>
-            <a:srgbClr val="B85042"/>
+            <a:srgbClr val="6B7280"/>
           </a:solidFill>
           <a:ln w="12700">
             <a:solidFill>
-              <a:srgbClr val="B85042"/>
+              <a:srgbClr val="6B7280"/>
             </a:solidFill>
             <a:prstDash val="solid"/>
           </a:ln>
@@ -8043,11 +8068,11 @@
             <a:avLst/>
           </a:prstGeom>
           <a:solidFill>
-            <a:srgbClr val="1E2761"/>
+            <a:srgbClr val="1E3A5F"/>
           </a:solidFill>
           <a:ln w="12700">
             <a:solidFill>
-              <a:srgbClr val="1E2761"/>
+              <a:srgbClr val="1E3A5F"/>
             </a:solidFill>
             <a:prstDash val="solid"/>
           </a:ln>
@@ -8158,7 +8183,7 @@
             <a:r>
               <a:rPr lang="en-US" sz="1400" i="1" dirty="0">
                 <a:solidFill>
-                  <a:srgbClr val="1E2761"/>
+                  <a:srgbClr val="1E3A5F"/>
                 </a:solidFill>
                 <a:latin typeface="Calibri" pitchFamily="34" charset="0"/>
                 <a:ea typeface="Calibri" pitchFamily="34" charset="-122"/>
@@ -8197,7 +8222,7 @@
             <a:r>
               <a:rPr lang="en-US" sz="1000" dirty="0">
                 <a:solidFill>
-                  <a:srgbClr val="888888"/>
+                  <a:srgbClr val="6B7280"/>
                 </a:solidFill>
                 <a:latin typeface="Calibri" pitchFamily="34" charset="0"/>
                 <a:ea typeface="Calibri" pitchFamily="34" charset="-122"/>
@@ -8256,11 +8281,11 @@
             <a:avLst/>
           </a:prstGeom>
           <a:solidFill>
-            <a:srgbClr val="B85042"/>
+            <a:srgbClr val="6B7280"/>
           </a:solidFill>
           <a:ln w="12700">
             <a:solidFill>
-              <a:srgbClr val="B85042"/>
+              <a:srgbClr val="6B7280"/>
             </a:solidFill>
             <a:prstDash val="solid"/>
           </a:ln>
@@ -8293,7 +8318,7 @@
             <a:r>
               <a:rPr lang="en-US" sz="1400" b="1" spc="400" kern="0" dirty="0">
                 <a:solidFill>
-                  <a:srgbClr val="B85042"/>
+                  <a:srgbClr val="6B7280"/>
                 </a:solidFill>
                 <a:latin typeface="Calibri" pitchFamily="34" charset="0"/>
                 <a:ea typeface="Calibri" pitchFamily="34" charset="-122"/>
@@ -8332,7 +8357,7 @@
             <a:r>
               <a:rPr lang="en-US" sz="4000" b="1" dirty="0">
                 <a:solidFill>
-                  <a:srgbClr val="1E2761"/>
+                  <a:srgbClr val="1E3A5F"/>
                 </a:solidFill>
                 <a:latin typeface="Calibri" pitchFamily="34" charset="0"/>
                 <a:ea typeface="Calibri" pitchFamily="34" charset="-122"/>
@@ -8359,11 +8384,11 @@
             <a:avLst/>
           </a:prstGeom>
           <a:solidFill>
-            <a:srgbClr val="B85042"/>
+            <a:srgbClr val="6B7280"/>
           </a:solidFill>
           <a:ln w="12700">
             <a:solidFill>
-              <a:srgbClr val="B85042"/>
+              <a:srgbClr val="6B7280"/>
             </a:solidFill>
             <a:prstDash val="solid"/>
           </a:ln>
@@ -8396,7 +8421,7 @@
             <a:r>
               <a:rPr lang="en-US" sz="1800" b="1" dirty="0">
                 <a:solidFill>
-                  <a:srgbClr val="1E2761"/>
+                  <a:srgbClr val="1E3A5F"/>
                 </a:solidFill>
                 <a:latin typeface="Calibri" pitchFamily="34" charset="0"/>
                 <a:ea typeface="Calibri" pitchFamily="34" charset="-122"/>
@@ -8462,11 +8487,11 @@
             <a:avLst/>
           </a:prstGeom>
           <a:solidFill>
-            <a:srgbClr val="B85042"/>
+            <a:srgbClr val="6B7280"/>
           </a:solidFill>
           <a:ln w="12700">
             <a:solidFill>
-              <a:srgbClr val="B85042"/>
+              <a:srgbClr val="6B7280"/>
             </a:solidFill>
             <a:prstDash val="solid"/>
           </a:ln>
@@ -8499,7 +8524,7 @@
             <a:r>
               <a:rPr lang="en-US" sz="1800" b="1" dirty="0">
                 <a:solidFill>
-                  <a:srgbClr val="1E2761"/>
+                  <a:srgbClr val="1E3A5F"/>
                 </a:solidFill>
                 <a:latin typeface="Calibri" pitchFamily="34" charset="0"/>
                 <a:ea typeface="Calibri" pitchFamily="34" charset="-122"/>
@@ -8565,11 +8590,11 @@
             <a:avLst/>
           </a:prstGeom>
           <a:solidFill>
-            <a:srgbClr val="B85042"/>
+            <a:srgbClr val="6B7280"/>
           </a:solidFill>
           <a:ln w="12700">
             <a:solidFill>
-              <a:srgbClr val="B85042"/>
+              <a:srgbClr val="6B7280"/>
             </a:solidFill>
             <a:prstDash val="solid"/>
           </a:ln>
@@ -8602,7 +8627,7 @@
             <a:r>
               <a:rPr lang="en-US" sz="1800" b="1" dirty="0">
                 <a:solidFill>
-                  <a:srgbClr val="1E2761"/>
+                  <a:srgbClr val="1E3A5F"/>
                 </a:solidFill>
                 <a:latin typeface="Calibri" pitchFamily="34" charset="0"/>
                 <a:ea typeface="Calibri" pitchFamily="34" charset="-122"/>
@@ -8668,11 +8693,11 @@
             <a:avLst/>
           </a:prstGeom>
           <a:solidFill>
-            <a:srgbClr val="B85042"/>
+            <a:srgbClr val="6B7280"/>
           </a:solidFill>
           <a:ln w="12700">
             <a:solidFill>
-              <a:srgbClr val="B85042"/>
+              <a:srgbClr val="6B7280"/>
             </a:solidFill>
             <a:prstDash val="solid"/>
           </a:ln>
@@ -8705,7 +8730,7 @@
             <a:r>
               <a:rPr lang="en-US" sz="1800" b="1" dirty="0">
                 <a:solidFill>
-                  <a:srgbClr val="1E2761"/>
+                  <a:srgbClr val="1E3A5F"/>
                 </a:solidFill>
                 <a:latin typeface="Calibri" pitchFamily="34" charset="0"/>
                 <a:ea typeface="Calibri" pitchFamily="34" charset="-122"/>
@@ -8783,7 +8808,7 @@
             <a:r>
               <a:rPr lang="en-US" sz="1000" dirty="0">
                 <a:solidFill>
-                  <a:srgbClr val="888888"/>
+                  <a:srgbClr val="6B7280"/>
                 </a:solidFill>
                 <a:latin typeface="Calibri" pitchFamily="34" charset="0"/>
                 <a:ea typeface="Calibri" pitchFamily="34" charset="-122"/>
@@ -8842,11 +8867,11 @@
             <a:avLst/>
           </a:prstGeom>
           <a:solidFill>
-            <a:srgbClr val="B85042"/>
+            <a:srgbClr val="6B7280"/>
           </a:solidFill>
           <a:ln w="12700">
             <a:solidFill>
-              <a:srgbClr val="B85042"/>
+              <a:srgbClr val="6B7280"/>
             </a:solidFill>
             <a:prstDash val="solid"/>
           </a:ln>
@@ -8879,7 +8904,7 @@
             <a:r>
               <a:rPr lang="en-US" sz="1400" b="1" spc="400" kern="0" dirty="0">
                 <a:solidFill>
-                  <a:srgbClr val="B85042"/>
+                  <a:srgbClr val="6B7280"/>
                 </a:solidFill>
                 <a:latin typeface="Calibri" pitchFamily="34" charset="0"/>
                 <a:ea typeface="Calibri" pitchFamily="34" charset="-122"/>
@@ -8918,7 +8943,7 @@
             <a:r>
               <a:rPr lang="en-US" sz="4000" b="1" dirty="0">
                 <a:solidFill>
-                  <a:srgbClr val="1E2761"/>
+                  <a:srgbClr val="1E3A5F"/>
                 </a:solidFill>
                 <a:latin typeface="Calibri" pitchFamily="34" charset="0"/>
                 <a:ea typeface="Calibri" pitchFamily="34" charset="-122"/>
@@ -8957,7 +8982,7 @@
             <a:r>
               <a:rPr lang="en-US" sz="1600" b="1" dirty="0">
                 <a:solidFill>
-                  <a:srgbClr val="1E2761"/>
+                  <a:srgbClr val="1E3A5F"/>
                 </a:solidFill>
                 <a:latin typeface="Calibri" pitchFamily="34" charset="0"/>
                 <a:ea typeface="Calibri" pitchFamily="34" charset="-122"/>
@@ -9101,7 +9126,7 @@
             <a:avLst/>
           </a:prstGeom>
           <a:solidFill>
-            <a:srgbClr val="F8F6F2"/>
+            <a:srgbClr val="F4F5F7"/>
           </a:solidFill>
           <a:ln w="12700">
             <a:solidFill>
@@ -9138,7 +9163,7 @@
             <a:r>
               <a:rPr lang="en-US" sz="1400" b="1" spc="200" kern="0" dirty="0">
                 <a:solidFill>
-                  <a:srgbClr val="B85042"/>
+                  <a:srgbClr val="6B7280"/>
                 </a:solidFill>
                 <a:latin typeface="Calibri" pitchFamily="34" charset="0"/>
                 <a:ea typeface="Calibri" pitchFamily="34" charset="-122"/>
@@ -9177,7 +9202,7 @@
             <a:r>
               <a:rPr lang="en-US" sz="1600" b="1" dirty="0">
                 <a:solidFill>
-                  <a:srgbClr val="1E2761"/>
+                  <a:srgbClr val="1E3A5F"/>
                 </a:solidFill>
                 <a:latin typeface="Calibri" pitchFamily="34" charset="0"/>
                 <a:ea typeface="Calibri" pitchFamily="34" charset="-122"/>
@@ -9216,7 +9241,7 @@
             <a:r>
               <a:rPr lang="en-US" sz="1200" dirty="0">
                 <a:solidFill>
-                  <a:srgbClr val="888888"/>
+                  <a:srgbClr val="6B7280"/>
                 </a:solidFill>
                 <a:latin typeface="Calibri" pitchFamily="34" charset="0"/>
                 <a:ea typeface="Calibri" pitchFamily="34" charset="-122"/>
@@ -9255,7 +9280,7 @@
             <a:r>
               <a:rPr lang="en-US" sz="1600" b="1" dirty="0">
                 <a:solidFill>
-                  <a:srgbClr val="1E2761"/>
+                  <a:srgbClr val="1E3A5F"/>
                 </a:solidFill>
                 <a:latin typeface="Calibri" pitchFamily="34" charset="0"/>
                 <a:ea typeface="Calibri" pitchFamily="34" charset="-122"/>
@@ -9294,7 +9319,7 @@
             <a:r>
               <a:rPr lang="en-US" sz="1200" dirty="0">
                 <a:solidFill>
-                  <a:srgbClr val="888888"/>
+                  <a:srgbClr val="6B7280"/>
                 </a:solidFill>
                 <a:latin typeface="Calibri" pitchFamily="34" charset="0"/>
                 <a:ea typeface="Calibri" pitchFamily="34" charset="-122"/>
@@ -9333,7 +9358,7 @@
             <a:r>
               <a:rPr lang="en-US" sz="1000" dirty="0">
                 <a:solidFill>
-                  <a:srgbClr val="888888"/>
+                  <a:srgbClr val="6B7280"/>
                 </a:solidFill>
                 <a:latin typeface="Calibri" pitchFamily="34" charset="0"/>
                 <a:ea typeface="Calibri" pitchFamily="34" charset="-122"/>
@@ -9392,11 +9417,11 @@
             <a:avLst/>
           </a:prstGeom>
           <a:solidFill>
-            <a:srgbClr val="B85042"/>
+            <a:srgbClr val="6B7280"/>
           </a:solidFill>
           <a:ln w="12700">
             <a:solidFill>
-              <a:srgbClr val="B85042"/>
+              <a:srgbClr val="6B7280"/>
             </a:solidFill>
             <a:prstDash val="solid"/>
           </a:ln>
@@ -9429,7 +9454,7 @@
             <a:r>
               <a:rPr lang="en-US" sz="1400" b="1" spc="400" kern="0" dirty="0">
                 <a:solidFill>
-                  <a:srgbClr val="B85042"/>
+                  <a:srgbClr val="6B7280"/>
                 </a:solidFill>
                 <a:latin typeface="Calibri" pitchFamily="34" charset="0"/>
                 <a:ea typeface="Calibri" pitchFamily="34" charset="-122"/>
@@ -9468,7 +9493,7 @@
             <a:r>
               <a:rPr lang="en-US" sz="4000" b="1" dirty="0">
                 <a:solidFill>
-                  <a:srgbClr val="1E2761"/>
+                  <a:srgbClr val="1E3A5F"/>
                 </a:solidFill>
                 <a:latin typeface="Calibri" pitchFamily="34" charset="0"/>
                 <a:ea typeface="Calibri" pitchFamily="34" charset="-122"/>
@@ -9495,7 +9520,7 @@
             <a:avLst/>
           </a:prstGeom>
           <a:solidFill>
-            <a:srgbClr val="F8F6F2"/>
+            <a:srgbClr val="F4F5F7"/>
           </a:solidFill>
           <a:ln w="12700">
             <a:solidFill>
@@ -9571,7 +9596,7 @@
             <a:r>
               <a:rPr lang="en-US" sz="2000" i="1" dirty="0">
                 <a:solidFill>
-                  <a:srgbClr val="B85042"/>
+                  <a:srgbClr val="6B7280"/>
                 </a:solidFill>
                 <a:latin typeface="Calibri" pitchFamily="34" charset="0"/>
                 <a:ea typeface="Calibri" pitchFamily="34" charset="-122"/>
@@ -9598,11 +9623,11 @@
             <a:avLst/>
           </a:prstGeom>
           <a:solidFill>
-            <a:srgbClr val="1E2761"/>
+            <a:srgbClr val="1E3A5F"/>
           </a:solidFill>
           <a:ln w="12700">
             <a:solidFill>
-              <a:srgbClr val="1E2761"/>
+              <a:srgbClr val="1E3A5F"/>
             </a:solidFill>
             <a:prstDash val="solid"/>
           </a:ln>
@@ -9674,7 +9699,7 @@
             <a:r>
               <a:rPr lang="en-US" sz="1400" dirty="0">
                 <a:solidFill>
-                  <a:srgbClr val="CADCFC"/>
+                  <a:srgbClr val="9CA3AF"/>
                 </a:solidFill>
                 <a:latin typeface="Calibri" pitchFamily="34" charset="0"/>
                 <a:ea typeface="Calibri" pitchFamily="34" charset="-122"/>
@@ -9701,11 +9726,11 @@
             <a:avLst/>
           </a:prstGeom>
           <a:solidFill>
-            <a:srgbClr val="1E2761"/>
+            <a:srgbClr val="1E3A5F"/>
           </a:solidFill>
           <a:ln w="12700">
             <a:solidFill>
-              <a:srgbClr val="1E2761"/>
+              <a:srgbClr val="1E3A5F"/>
             </a:solidFill>
             <a:prstDash val="solid"/>
           </a:ln>
@@ -9777,7 +9802,7 @@
             <a:r>
               <a:rPr lang="en-US" sz="1400" dirty="0">
                 <a:solidFill>
-                  <a:srgbClr val="CADCFC"/>
+                  <a:srgbClr val="9CA3AF"/>
                 </a:solidFill>
                 <a:latin typeface="Calibri" pitchFamily="34" charset="0"/>
                 <a:ea typeface="Calibri" pitchFamily="34" charset="-122"/>
@@ -9804,11 +9829,11 @@
             <a:avLst/>
           </a:prstGeom>
           <a:solidFill>
-            <a:srgbClr val="1E2761"/>
+            <a:srgbClr val="1E3A5F"/>
           </a:solidFill>
           <a:ln w="12700">
             <a:solidFill>
-              <a:srgbClr val="1E2761"/>
+              <a:srgbClr val="1E3A5F"/>
             </a:solidFill>
             <a:prstDash val="solid"/>
           </a:ln>
@@ -9880,7 +9905,7 @@
             <a:r>
               <a:rPr lang="en-US" sz="1400" dirty="0">
                 <a:solidFill>
-                  <a:srgbClr val="CADCFC"/>
+                  <a:srgbClr val="9CA3AF"/>
                 </a:solidFill>
                 <a:latin typeface="Calibri" pitchFamily="34" charset="0"/>
                 <a:ea typeface="Calibri" pitchFamily="34" charset="-122"/>
@@ -9919,7 +9944,7 @@
             <a:r>
               <a:rPr lang="en-US" sz="1000" dirty="0">
                 <a:solidFill>
-                  <a:srgbClr val="888888"/>
+                  <a:srgbClr val="6B7280"/>
                 </a:solidFill>
                 <a:latin typeface="Calibri" pitchFamily="34" charset="0"/>
                 <a:ea typeface="Calibri" pitchFamily="34" charset="-122"/>
@@ -9958,7 +9983,7 @@
             <a:r>
               <a:rPr lang="en-US" sz="1000" dirty="0">
                 <a:solidFill>
-                  <a:srgbClr val="888888"/>
+                  <a:srgbClr val="6B7280"/>
                 </a:solidFill>
                 <a:latin typeface="Calibri" pitchFamily="34" charset="0"/>
                 <a:ea typeface="Calibri" pitchFamily="34" charset="-122"/>
@@ -10017,11 +10042,11 @@
             <a:avLst/>
           </a:prstGeom>
           <a:solidFill>
-            <a:srgbClr val="B85042"/>
+            <a:srgbClr val="6B7280"/>
           </a:solidFill>
           <a:ln w="12700">
             <a:solidFill>
-              <a:srgbClr val="B85042"/>
+              <a:srgbClr val="6B7280"/>
             </a:solidFill>
             <a:prstDash val="solid"/>
           </a:ln>
@@ -10054,7 +10079,7 @@
             <a:r>
               <a:rPr lang="en-US" sz="1400" b="1" spc="400" kern="0" dirty="0">
                 <a:solidFill>
-                  <a:srgbClr val="B85042"/>
+                  <a:srgbClr val="6B7280"/>
                 </a:solidFill>
                 <a:latin typeface="Calibri" pitchFamily="34" charset="0"/>
                 <a:ea typeface="Calibri" pitchFamily="34" charset="-122"/>
@@ -10093,7 +10118,7 @@
             <a:r>
               <a:rPr lang="en-US" sz="4000" b="1" dirty="0">
                 <a:solidFill>
-                  <a:srgbClr val="1E2761"/>
+                  <a:srgbClr val="1E3A5F"/>
                 </a:solidFill>
                 <a:latin typeface="Calibri" pitchFamily="34" charset="0"/>
                 <a:ea typeface="Calibri" pitchFamily="34" charset="-122"/>
@@ -10120,11 +10145,11 @@
             <a:avLst/>
           </a:prstGeom>
           <a:solidFill>
-            <a:srgbClr val="B85042"/>
+            <a:srgbClr val="6B7280"/>
           </a:solidFill>
           <a:ln w="12700">
             <a:solidFill>
-              <a:srgbClr val="B85042"/>
+              <a:srgbClr val="6B7280"/>
             </a:solidFill>
             <a:prstDash val="solid"/>
           </a:ln>
@@ -10145,11 +10170,11 @@
             <a:avLst/>
           </a:prstGeom>
           <a:solidFill>
-            <a:srgbClr val="1E2761"/>
+            <a:srgbClr val="1E3A5F"/>
           </a:solidFill>
           <a:ln w="12700">
             <a:solidFill>
-              <a:srgbClr val="1E2761"/>
+              <a:srgbClr val="1E3A5F"/>
             </a:solidFill>
             <a:prstDash val="solid"/>
           </a:ln>
@@ -10182,7 +10207,7 @@
             <a:r>
               <a:rPr lang="en-US" sz="1400" b="1" dirty="0">
                 <a:solidFill>
-                  <a:srgbClr val="B85042"/>
+                  <a:srgbClr val="6B7280"/>
                 </a:solidFill>
                 <a:latin typeface="Calibri" pitchFamily="34" charset="0"/>
                 <a:ea typeface="Calibri" pitchFamily="34" charset="-122"/>
@@ -10221,7 +10246,7 @@
             <a:r>
               <a:rPr lang="en-US" sz="1800" b="1" dirty="0">
                 <a:solidFill>
-                  <a:srgbClr val="1E2761"/>
+                  <a:srgbClr val="1E3A5F"/>
                 </a:solidFill>
                 <a:latin typeface="Calibri" pitchFamily="34" charset="0"/>
                 <a:ea typeface="Calibri" pitchFamily="34" charset="-122"/>
@@ -10287,11 +10312,11 @@
             <a:avLst/>
           </a:prstGeom>
           <a:solidFill>
-            <a:srgbClr val="1E2761"/>
+            <a:srgbClr val="1E3A5F"/>
           </a:solidFill>
           <a:ln w="12700">
             <a:solidFill>
-              <a:srgbClr val="1E2761"/>
+              <a:srgbClr val="1E3A5F"/>
             </a:solidFill>
             <a:prstDash val="solid"/>
           </a:ln>
@@ -10324,7 +10349,7 @@
             <a:r>
               <a:rPr lang="en-US" sz="1400" b="1" dirty="0">
                 <a:solidFill>
-                  <a:srgbClr val="B85042"/>
+                  <a:srgbClr val="6B7280"/>
                 </a:solidFill>
                 <a:latin typeface="Calibri" pitchFamily="34" charset="0"/>
                 <a:ea typeface="Calibri" pitchFamily="34" charset="-122"/>
@@ -10363,7 +10388,7 @@
             <a:r>
               <a:rPr lang="en-US" sz="1800" b="1" dirty="0">
                 <a:solidFill>
-                  <a:srgbClr val="1E2761"/>
+                  <a:srgbClr val="1E3A5F"/>
                 </a:solidFill>
                 <a:latin typeface="Calibri" pitchFamily="34" charset="0"/>
                 <a:ea typeface="Calibri" pitchFamily="34" charset="-122"/>
@@ -10429,11 +10454,11 @@
             <a:avLst/>
           </a:prstGeom>
           <a:solidFill>
-            <a:srgbClr val="1E2761"/>
+            <a:srgbClr val="1E3A5F"/>
           </a:solidFill>
           <a:ln w="12700">
             <a:solidFill>
-              <a:srgbClr val="1E2761"/>
+              <a:srgbClr val="1E3A5F"/>
             </a:solidFill>
             <a:prstDash val="solid"/>
           </a:ln>
@@ -10466,7 +10491,7 @@
             <a:r>
               <a:rPr lang="en-US" sz="1400" b="1" dirty="0">
                 <a:solidFill>
-                  <a:srgbClr val="B85042"/>
+                  <a:srgbClr val="6B7280"/>
                 </a:solidFill>
                 <a:latin typeface="Calibri" pitchFamily="34" charset="0"/>
                 <a:ea typeface="Calibri" pitchFamily="34" charset="-122"/>
@@ -10505,7 +10530,7 @@
             <a:r>
               <a:rPr lang="en-US" sz="1800" b="1" dirty="0">
                 <a:solidFill>
-                  <a:srgbClr val="1E2761"/>
+                  <a:srgbClr val="1E3A5F"/>
                 </a:solidFill>
                 <a:latin typeface="Calibri" pitchFamily="34" charset="0"/>
                 <a:ea typeface="Calibri" pitchFamily="34" charset="-122"/>
@@ -10571,11 +10596,11 @@
             <a:avLst/>
           </a:prstGeom>
           <a:solidFill>
-            <a:srgbClr val="1E2761"/>
+            <a:srgbClr val="1E3A5F"/>
           </a:solidFill>
           <a:ln w="12700">
             <a:solidFill>
-              <a:srgbClr val="1E2761"/>
+              <a:srgbClr val="1E3A5F"/>
             </a:solidFill>
             <a:prstDash val="solid"/>
           </a:ln>
@@ -10608,7 +10633,7 @@
             <a:r>
               <a:rPr lang="en-US" sz="1400" b="1" dirty="0">
                 <a:solidFill>
-                  <a:srgbClr val="B85042"/>
+                  <a:srgbClr val="6B7280"/>
                 </a:solidFill>
                 <a:latin typeface="Calibri" pitchFamily="34" charset="0"/>
                 <a:ea typeface="Calibri" pitchFamily="34" charset="-122"/>
@@ -10647,7 +10672,7 @@
             <a:r>
               <a:rPr lang="en-US" sz="1800" b="1" dirty="0">
                 <a:solidFill>
-                  <a:srgbClr val="1E2761"/>
+                  <a:srgbClr val="1E3A5F"/>
                 </a:solidFill>
                 <a:latin typeface="Calibri" pitchFamily="34" charset="0"/>
                 <a:ea typeface="Calibri" pitchFamily="34" charset="-122"/>
@@ -10725,7 +10750,7 @@
             <a:r>
               <a:rPr lang="en-US" sz="1000" dirty="0">
                 <a:solidFill>
-                  <a:srgbClr val="888888"/>
+                  <a:srgbClr val="6B7280"/>
                 </a:solidFill>
                 <a:latin typeface="Calibri" pitchFamily="34" charset="0"/>
                 <a:ea typeface="Calibri" pitchFamily="34" charset="-122"/>
@@ -10751,7 +10776,7 @@
     <p:bg>
       <p:bgPr>
         <a:solidFill>
-          <a:srgbClr val="1E2761"/>
+          <a:srgbClr val="FFFFFF"/>
         </a:solidFill>
       </p:bgPr>
     </p:bg>
@@ -10778,17 +10803,17 @@
         <p:spPr>
           <a:xfrm>
             <a:off x="0" y="0"/>
-            <a:ext cx="365760" cy="6858000"/>
+            <a:ext cx="109728" cy="6858000"/>
           </a:xfrm>
           <a:prstGeom prst="rect">
             <a:avLst/>
           </a:prstGeom>
           <a:solidFill>
-            <a:srgbClr val="B85042"/>
+            <a:srgbClr val="6B7280"/>
           </a:solidFill>
           <a:ln w="12700">
             <a:solidFill>
-              <a:srgbClr val="B85042"/>
+              <a:srgbClr val="6B7280"/>
             </a:solidFill>
             <a:prstDash val="solid"/>
           </a:ln>
@@ -10821,7 +10846,7 @@
             <a:r>
               <a:rPr lang="en-US" sz="1600" b="1" spc="400" kern="0" dirty="0">
                 <a:solidFill>
-                  <a:srgbClr val="CADCFC"/>
+                  <a:srgbClr val="6B7280"/>
                 </a:solidFill>
                 <a:latin typeface="Calibri" pitchFamily="34" charset="0"/>
                 <a:ea typeface="Calibri" pitchFamily="34" charset="-122"/>
@@ -10860,7 +10885,7 @@
             <a:r>
               <a:rPr lang="en-US" sz="5600" b="1" dirty="0">
                 <a:solidFill>
-                  <a:srgbClr val="FFFFFF"/>
+                  <a:srgbClr val="1E3A5F"/>
                 </a:solidFill>
                 <a:latin typeface="Calibri" pitchFamily="34" charset="0"/>
                 <a:ea typeface="Calibri" pitchFamily="34" charset="-122"/>
@@ -10887,11 +10912,11 @@
             <a:avLst/>
           </a:prstGeom>
           <a:solidFill>
-            <a:srgbClr val="0F1737"/>
+            <a:srgbClr val="F4F5F7"/>
           </a:solidFill>
           <a:ln w="12700">
             <a:solidFill>
-              <a:srgbClr val="B85042"/>
+              <a:srgbClr val="D1D5DB"/>
             </a:solidFill>
             <a:prstDash val="solid"/>
           </a:ln>
@@ -10924,7 +10949,7 @@
             <a:r>
               <a:rPr lang="en-US" sz="2200" b="1" dirty="0">
                 <a:solidFill>
-                  <a:srgbClr val="B85042"/>
+                  <a:srgbClr val="6B7280"/>
                 </a:solidFill>
                 <a:latin typeface="Calibri" pitchFamily="34" charset="0"/>
                 <a:ea typeface="Calibri" pitchFamily="34" charset="-122"/>
@@ -10963,7 +10988,7 @@
             <a:r>
               <a:rPr lang="en-US" sz="1400" dirty="0">
                 <a:solidFill>
-                  <a:srgbClr val="FFFFFF"/>
+                  <a:srgbClr val="1A1A1A"/>
                 </a:solidFill>
                 <a:latin typeface="Calibri" pitchFamily="34" charset="0"/>
                 <a:ea typeface="Calibri" pitchFamily="34" charset="-122"/>
@@ -10990,11 +11015,11 @@
             <a:avLst/>
           </a:prstGeom>
           <a:solidFill>
-            <a:srgbClr val="0F1737"/>
+            <a:srgbClr val="F4F5F7"/>
           </a:solidFill>
           <a:ln w="12700">
             <a:solidFill>
-              <a:srgbClr val="B85042"/>
+              <a:srgbClr val="D1D5DB"/>
             </a:solidFill>
             <a:prstDash val="solid"/>
           </a:ln>
@@ -11027,7 +11052,7 @@
             <a:r>
               <a:rPr lang="en-US" sz="2200" b="1" dirty="0">
                 <a:solidFill>
-                  <a:srgbClr val="B85042"/>
+                  <a:srgbClr val="6B7280"/>
                 </a:solidFill>
                 <a:latin typeface="Calibri" pitchFamily="34" charset="0"/>
                 <a:ea typeface="Calibri" pitchFamily="34" charset="-122"/>
@@ -11066,7 +11091,7 @@
             <a:r>
               <a:rPr lang="en-US" sz="1400" dirty="0">
                 <a:solidFill>
-                  <a:srgbClr val="FFFFFF"/>
+                  <a:srgbClr val="1A1A1A"/>
                 </a:solidFill>
                 <a:latin typeface="Calibri" pitchFamily="34" charset="0"/>
                 <a:ea typeface="Calibri" pitchFamily="34" charset="-122"/>
@@ -11093,11 +11118,11 @@
             <a:avLst/>
           </a:prstGeom>
           <a:solidFill>
-            <a:srgbClr val="0F1737"/>
+            <a:srgbClr val="F4F5F7"/>
           </a:solidFill>
           <a:ln w="12700">
             <a:solidFill>
-              <a:srgbClr val="B85042"/>
+              <a:srgbClr val="D1D5DB"/>
             </a:solidFill>
             <a:prstDash val="solid"/>
           </a:ln>
@@ -11130,7 +11155,7 @@
             <a:r>
               <a:rPr lang="en-US" sz="2200" b="1" dirty="0">
                 <a:solidFill>
-                  <a:srgbClr val="B85042"/>
+                  <a:srgbClr val="6B7280"/>
                 </a:solidFill>
                 <a:latin typeface="Calibri" pitchFamily="34" charset="0"/>
                 <a:ea typeface="Calibri" pitchFamily="34" charset="-122"/>
@@ -11169,7 +11194,7 @@
             <a:r>
               <a:rPr lang="en-US" sz="1400" dirty="0">
                 <a:solidFill>
-                  <a:srgbClr val="FFFFFF"/>
+                  <a:srgbClr val="1A1A1A"/>
                 </a:solidFill>
                 <a:latin typeface="Calibri" pitchFamily="34" charset="0"/>
                 <a:ea typeface="Calibri" pitchFamily="34" charset="-122"/>
@@ -11208,7 +11233,7 @@
             <a:r>
               <a:rPr lang="en-US" sz="1800" i="1" dirty="0">
                 <a:solidFill>
-                  <a:srgbClr val="CADCFC"/>
+                  <a:srgbClr val="6B7280"/>
                 </a:solidFill>
                 <a:latin typeface="Calibri" pitchFamily="34" charset="0"/>
                 <a:ea typeface="Calibri" pitchFamily="34" charset="-122"/>
@@ -11234,7 +11259,7 @@
     <p:bg>
       <p:bgPr>
         <a:solidFill>
-          <a:srgbClr val="1E2761"/>
+          <a:srgbClr val="FFFFFF"/>
         </a:solidFill>
       </p:bgPr>
     </p:bg>
@@ -11261,17 +11286,17 @@
         <p:spPr>
           <a:xfrm>
             <a:off x="0" y="0"/>
-            <a:ext cx="365760" cy="6858000"/>
+            <a:ext cx="109728" cy="6858000"/>
           </a:xfrm>
           <a:prstGeom prst="rect">
             <a:avLst/>
           </a:prstGeom>
           <a:solidFill>
-            <a:srgbClr val="B85042"/>
+            <a:srgbClr val="6B7280"/>
           </a:solidFill>
           <a:ln w="12700">
             <a:solidFill>
-              <a:srgbClr val="B85042"/>
+              <a:srgbClr val="6B7280"/>
             </a:solidFill>
             <a:prstDash val="solid"/>
           </a:ln>
@@ -11304,7 +11329,7 @@
             <a:r>
               <a:rPr lang="en-US" sz="1800" b="1" spc="600" kern="0" dirty="0">
                 <a:solidFill>
-                  <a:srgbClr val="CADCFC"/>
+                  <a:srgbClr val="6B7280"/>
                 </a:solidFill>
                 <a:latin typeface="Calibri" pitchFamily="34" charset="0"/>
                 <a:ea typeface="Calibri" pitchFamily="34" charset="-122"/>
@@ -11343,7 +11368,7 @@
             <a:r>
               <a:rPr lang="en-US" sz="7200" b="1" dirty="0">
                 <a:solidFill>
-                  <a:srgbClr val="FFFFFF"/>
+                  <a:srgbClr val="1E3A5F"/>
                 </a:solidFill>
                 <a:latin typeface="Calibri" pitchFamily="34" charset="0"/>
                 <a:ea typeface="Calibri" pitchFamily="34" charset="-122"/>
@@ -11382,7 +11407,7 @@
             <a:r>
               <a:rPr lang="en-US" sz="1800" i="1" dirty="0">
                 <a:solidFill>
-                  <a:srgbClr val="CADCFC"/>
+                  <a:srgbClr val="6B7280"/>
                 </a:solidFill>
                 <a:latin typeface="Calibri" pitchFamily="34" charset="0"/>
                 <a:ea typeface="Calibri" pitchFamily="34" charset="-122"/>
@@ -11421,7 +11446,7 @@
             <a:r>
               <a:rPr lang="en-US" sz="1400" dirty="0">
                 <a:solidFill>
-                  <a:srgbClr val="CADCFC"/>
+                  <a:srgbClr val="6B7280"/>
                 </a:solidFill>
                 <a:latin typeface="Calibri" pitchFamily="34" charset="0"/>
                 <a:ea typeface="Calibri" pitchFamily="34" charset="-122"/>
@@ -11480,11 +11505,11 @@
             <a:avLst/>
           </a:prstGeom>
           <a:solidFill>
-            <a:srgbClr val="B85042"/>
+            <a:srgbClr val="6B7280"/>
           </a:solidFill>
           <a:ln w="12700">
             <a:solidFill>
-              <a:srgbClr val="B85042"/>
+              <a:srgbClr val="6B7280"/>
             </a:solidFill>
             <a:prstDash val="solid"/>
           </a:ln>
@@ -11517,7 +11542,7 @@
             <a:r>
               <a:rPr lang="en-US" sz="1400" b="1" spc="400" kern="0" dirty="0">
                 <a:solidFill>
-                  <a:srgbClr val="B85042"/>
+                  <a:srgbClr val="6B7280"/>
                 </a:solidFill>
                 <a:latin typeface="Calibri" pitchFamily="34" charset="0"/>
                 <a:ea typeface="Calibri" pitchFamily="34" charset="-122"/>
@@ -11556,7 +11581,7 @@
             <a:r>
               <a:rPr lang="en-US" sz="4000" b="1" dirty="0">
                 <a:solidFill>
-                  <a:srgbClr val="1E2761"/>
+                  <a:srgbClr val="1E3A5F"/>
                 </a:solidFill>
                 <a:latin typeface="Calibri" pitchFamily="34" charset="0"/>
                 <a:ea typeface="Calibri" pitchFamily="34" charset="-122"/>
@@ -11583,11 +11608,11 @@
             <a:avLst/>
           </a:prstGeom>
           <a:solidFill>
-            <a:srgbClr val="B85042"/>
+            <a:srgbClr val="6B7280"/>
           </a:solidFill>
           <a:ln w="12700">
             <a:solidFill>
-              <a:srgbClr val="B85042"/>
+              <a:srgbClr val="6B7280"/>
             </a:solidFill>
             <a:prstDash val="solid"/>
           </a:ln>
@@ -11659,7 +11684,7 @@
             <a:r>
               <a:rPr lang="en-US" sz="1600" b="1" dirty="0">
                 <a:solidFill>
-                  <a:srgbClr val="1E2761"/>
+                  <a:srgbClr val="1E3A5F"/>
                 </a:solidFill>
                 <a:latin typeface="Calibri" pitchFamily="34" charset="0"/>
                 <a:ea typeface="Calibri" pitchFamily="34" charset="-122"/>
@@ -11725,11 +11750,11 @@
             <a:avLst/>
           </a:prstGeom>
           <a:solidFill>
-            <a:srgbClr val="B85042"/>
+            <a:srgbClr val="6B7280"/>
           </a:solidFill>
           <a:ln w="12700">
             <a:solidFill>
-              <a:srgbClr val="B85042"/>
+              <a:srgbClr val="6B7280"/>
             </a:solidFill>
             <a:prstDash val="solid"/>
           </a:ln>
@@ -11801,7 +11826,7 @@
             <a:r>
               <a:rPr lang="en-US" sz="1600" b="1" dirty="0">
                 <a:solidFill>
-                  <a:srgbClr val="1E2761"/>
+                  <a:srgbClr val="1E3A5F"/>
                 </a:solidFill>
                 <a:latin typeface="Calibri" pitchFamily="34" charset="0"/>
                 <a:ea typeface="Calibri" pitchFamily="34" charset="-122"/>
@@ -11867,11 +11892,11 @@
             <a:avLst/>
           </a:prstGeom>
           <a:solidFill>
-            <a:srgbClr val="B85042"/>
+            <a:srgbClr val="6B7280"/>
           </a:solidFill>
           <a:ln w="12700">
             <a:solidFill>
-              <a:srgbClr val="B85042"/>
+              <a:srgbClr val="6B7280"/>
             </a:solidFill>
             <a:prstDash val="solid"/>
           </a:ln>
@@ -11943,7 +11968,7 @@
             <a:r>
               <a:rPr lang="en-US" sz="1600" b="1" dirty="0">
                 <a:solidFill>
-                  <a:srgbClr val="1E2761"/>
+                  <a:srgbClr val="1E3A5F"/>
                 </a:solidFill>
                 <a:latin typeface="Calibri" pitchFamily="34" charset="0"/>
                 <a:ea typeface="Calibri" pitchFamily="34" charset="-122"/>
@@ -12009,11 +12034,11 @@
             <a:avLst/>
           </a:prstGeom>
           <a:solidFill>
-            <a:srgbClr val="B85042"/>
+            <a:srgbClr val="6B7280"/>
           </a:solidFill>
           <a:ln w="12700">
             <a:solidFill>
-              <a:srgbClr val="B85042"/>
+              <a:srgbClr val="6B7280"/>
             </a:solidFill>
             <a:prstDash val="solid"/>
           </a:ln>
@@ -12085,7 +12110,7 @@
             <a:r>
               <a:rPr lang="en-US" sz="1600" b="1" dirty="0">
                 <a:solidFill>
-                  <a:srgbClr val="1E2761"/>
+                  <a:srgbClr val="1E3A5F"/>
                 </a:solidFill>
                 <a:latin typeface="Calibri" pitchFamily="34" charset="0"/>
                 <a:ea typeface="Calibri" pitchFamily="34" charset="-122"/>
@@ -12151,11 +12176,11 @@
             <a:avLst/>
           </a:prstGeom>
           <a:solidFill>
-            <a:srgbClr val="B85042"/>
+            <a:srgbClr val="6B7280"/>
           </a:solidFill>
           <a:ln w="12700">
             <a:solidFill>
-              <a:srgbClr val="B85042"/>
+              <a:srgbClr val="6B7280"/>
             </a:solidFill>
             <a:prstDash val="solid"/>
           </a:ln>
@@ -12227,7 +12252,7 @@
             <a:r>
               <a:rPr lang="en-US" sz="1600" b="1" dirty="0">
                 <a:solidFill>
-                  <a:srgbClr val="1E2761"/>
+                  <a:srgbClr val="1E3A5F"/>
                 </a:solidFill>
                 <a:latin typeface="Calibri" pitchFamily="34" charset="0"/>
                 <a:ea typeface="Calibri" pitchFamily="34" charset="-122"/>
@@ -12293,11 +12318,11 @@
             <a:avLst/>
           </a:prstGeom>
           <a:solidFill>
-            <a:srgbClr val="B85042"/>
+            <a:srgbClr val="6B7280"/>
           </a:solidFill>
           <a:ln w="12700">
             <a:solidFill>
-              <a:srgbClr val="B85042"/>
+              <a:srgbClr val="6B7280"/>
             </a:solidFill>
             <a:prstDash val="solid"/>
           </a:ln>
@@ -12369,7 +12394,7 @@
             <a:r>
               <a:rPr lang="en-US" sz="1600" b="1" dirty="0">
                 <a:solidFill>
-                  <a:srgbClr val="1E2761"/>
+                  <a:srgbClr val="1E3A5F"/>
                 </a:solidFill>
                 <a:latin typeface="Calibri" pitchFamily="34" charset="0"/>
                 <a:ea typeface="Calibri" pitchFamily="34" charset="-122"/>
@@ -12435,11 +12460,11 @@
             <a:avLst/>
           </a:prstGeom>
           <a:solidFill>
-            <a:srgbClr val="B85042"/>
+            <a:srgbClr val="6B7280"/>
           </a:solidFill>
           <a:ln w="12700">
             <a:solidFill>
-              <a:srgbClr val="B85042"/>
+              <a:srgbClr val="6B7280"/>
             </a:solidFill>
             <a:prstDash val="solid"/>
           </a:ln>
@@ -12511,7 +12536,7 @@
             <a:r>
               <a:rPr lang="en-US" sz="1600" b="1" dirty="0">
                 <a:solidFill>
-                  <a:srgbClr val="1E2761"/>
+                  <a:srgbClr val="1E3A5F"/>
                 </a:solidFill>
                 <a:latin typeface="Calibri" pitchFamily="34" charset="0"/>
                 <a:ea typeface="Calibri" pitchFamily="34" charset="-122"/>
@@ -12589,7 +12614,7 @@
             <a:r>
               <a:rPr lang="en-US" sz="1000" dirty="0">
                 <a:solidFill>
-                  <a:srgbClr val="888888"/>
+                  <a:srgbClr val="6B7280"/>
                 </a:solidFill>
                 <a:latin typeface="Calibri" pitchFamily="34" charset="0"/>
                 <a:ea typeface="Calibri" pitchFamily="34" charset="-122"/>
@@ -12628,7 +12653,7 @@
             <a:r>
               <a:rPr lang="en-US" sz="1000" dirty="0">
                 <a:solidFill>
-                  <a:srgbClr val="888888"/>
+                  <a:srgbClr val="6B7280"/>
                 </a:solidFill>
                 <a:latin typeface="Calibri" pitchFamily="34" charset="0"/>
                 <a:ea typeface="Calibri" pitchFamily="34" charset="-122"/>
@@ -12687,11 +12712,11 @@
             <a:avLst/>
           </a:prstGeom>
           <a:solidFill>
-            <a:srgbClr val="B85042"/>
+            <a:srgbClr val="6B7280"/>
           </a:solidFill>
           <a:ln w="12700">
             <a:solidFill>
-              <a:srgbClr val="B85042"/>
+              <a:srgbClr val="6B7280"/>
             </a:solidFill>
             <a:prstDash val="solid"/>
           </a:ln>
@@ -12724,7 +12749,7 @@
             <a:r>
               <a:rPr lang="en-US" sz="1400" b="1" spc="400" kern="0" dirty="0">
                 <a:solidFill>
-                  <a:srgbClr val="B85042"/>
+                  <a:srgbClr val="6B7280"/>
                 </a:solidFill>
                 <a:latin typeface="Calibri" pitchFamily="34" charset="0"/>
                 <a:ea typeface="Calibri" pitchFamily="34" charset="-122"/>
@@ -12763,7 +12788,7 @@
             <a:r>
               <a:rPr lang="en-US" sz="4000" b="1" dirty="0">
                 <a:solidFill>
-                  <a:srgbClr val="1E2761"/>
+                  <a:srgbClr val="1E3A5F"/>
                 </a:solidFill>
                 <a:latin typeface="Calibri" pitchFamily="34" charset="0"/>
                 <a:ea typeface="Calibri" pitchFamily="34" charset="-122"/>
@@ -12790,11 +12815,11 @@
             <a:avLst/>
           </a:prstGeom>
           <a:solidFill>
-            <a:srgbClr val="B85042"/>
+            <a:srgbClr val="6B7280"/>
           </a:solidFill>
           <a:ln w="12700">
             <a:solidFill>
-              <a:srgbClr val="B85042"/>
+              <a:srgbClr val="6B7280"/>
             </a:solidFill>
             <a:prstDash val="solid"/>
           </a:ln>
@@ -12815,11 +12840,11 @@
             <a:avLst/>
           </a:prstGeom>
           <a:solidFill>
-            <a:srgbClr val="1E2761"/>
+            <a:srgbClr val="1E3A5F"/>
           </a:solidFill>
           <a:ln w="12700">
             <a:solidFill>
-              <a:srgbClr val="1E2761"/>
+              <a:srgbClr val="1E3A5F"/>
             </a:solidFill>
             <a:prstDash val="solid"/>
           </a:ln>
@@ -12852,7 +12877,7 @@
             <a:r>
               <a:rPr lang="en-US" sz="1800" b="1" dirty="0">
                 <a:solidFill>
-                  <a:srgbClr val="1E2761"/>
+                  <a:srgbClr val="1E3A5F"/>
                 </a:solidFill>
                 <a:latin typeface="Calibri" pitchFamily="34" charset="0"/>
                 <a:ea typeface="Calibri" pitchFamily="34" charset="-122"/>
@@ -12918,11 +12943,11 @@
             <a:avLst/>
           </a:prstGeom>
           <a:solidFill>
-            <a:srgbClr val="1E2761"/>
+            <a:srgbClr val="1E3A5F"/>
           </a:solidFill>
           <a:ln w="12700">
             <a:solidFill>
-              <a:srgbClr val="1E2761"/>
+              <a:srgbClr val="1E3A5F"/>
             </a:solidFill>
             <a:prstDash val="solid"/>
           </a:ln>
@@ -12955,7 +12980,7 @@
             <a:r>
               <a:rPr lang="en-US" sz="1800" b="1" dirty="0">
                 <a:solidFill>
-                  <a:srgbClr val="1E2761"/>
+                  <a:srgbClr val="1E3A5F"/>
                 </a:solidFill>
                 <a:latin typeface="Calibri" pitchFamily="34" charset="0"/>
                 <a:ea typeface="Calibri" pitchFamily="34" charset="-122"/>
@@ -13021,11 +13046,11 @@
             <a:avLst/>
           </a:prstGeom>
           <a:solidFill>
-            <a:srgbClr val="1E2761"/>
+            <a:srgbClr val="1E3A5F"/>
           </a:solidFill>
           <a:ln w="12700">
             <a:solidFill>
-              <a:srgbClr val="1E2761"/>
+              <a:srgbClr val="1E3A5F"/>
             </a:solidFill>
             <a:prstDash val="solid"/>
           </a:ln>
@@ -13058,7 +13083,7 @@
             <a:r>
               <a:rPr lang="en-US" sz="1800" b="1" dirty="0">
                 <a:solidFill>
-                  <a:srgbClr val="1E2761"/>
+                  <a:srgbClr val="1E3A5F"/>
                 </a:solidFill>
                 <a:latin typeface="Calibri" pitchFamily="34" charset="0"/>
                 <a:ea typeface="Calibri" pitchFamily="34" charset="-122"/>
@@ -13124,11 +13149,11 @@
             <a:avLst/>
           </a:prstGeom>
           <a:solidFill>
-            <a:srgbClr val="1E2761"/>
+            <a:srgbClr val="1E3A5F"/>
           </a:solidFill>
           <a:ln w="12700">
             <a:solidFill>
-              <a:srgbClr val="1E2761"/>
+              <a:srgbClr val="1E3A5F"/>
             </a:solidFill>
             <a:prstDash val="solid"/>
           </a:ln>
@@ -13161,7 +13186,7 @@
             <a:r>
               <a:rPr lang="en-US" sz="1800" b="1" dirty="0">
                 <a:solidFill>
-                  <a:srgbClr val="1E2761"/>
+                  <a:srgbClr val="1E3A5F"/>
                 </a:solidFill>
                 <a:latin typeface="Calibri" pitchFamily="34" charset="0"/>
                 <a:ea typeface="Calibri" pitchFamily="34" charset="-122"/>
@@ -13227,11 +13252,11 @@
             <a:avLst/>
           </a:prstGeom>
           <a:solidFill>
-            <a:srgbClr val="1E2761"/>
+            <a:srgbClr val="1E3A5F"/>
           </a:solidFill>
           <a:ln w="12700">
             <a:solidFill>
-              <a:srgbClr val="1E2761"/>
+              <a:srgbClr val="1E3A5F"/>
             </a:solidFill>
             <a:prstDash val="solid"/>
           </a:ln>
@@ -13264,7 +13289,7 @@
             <a:r>
               <a:rPr lang="en-US" sz="1800" b="1" dirty="0">
                 <a:solidFill>
-                  <a:srgbClr val="1E2761"/>
+                  <a:srgbClr val="1E3A5F"/>
                 </a:solidFill>
                 <a:latin typeface="Calibri" pitchFamily="34" charset="0"/>
                 <a:ea typeface="Calibri" pitchFamily="34" charset="-122"/>
@@ -13330,7 +13355,7 @@
             <a:avLst/>
           </a:prstGeom>
           <a:solidFill>
-            <a:srgbClr val="F8F6F2"/>
+            <a:srgbClr val="F4F5F7"/>
           </a:solidFill>
           <a:ln w="12700">
             <a:solidFill>
@@ -13367,7 +13392,7 @@
             <a:r>
               <a:rPr lang="en-US" sz="3600" b="1" dirty="0">
                 <a:solidFill>
-                  <a:srgbClr val="B85042"/>
+                  <a:srgbClr val="6B7280"/>
                 </a:solidFill>
                 <a:latin typeface="Calibri" pitchFamily="34" charset="0"/>
                 <a:ea typeface="Calibri" pitchFamily="34" charset="-122"/>
@@ -13433,7 +13458,7 @@
             <a:avLst/>
           </a:prstGeom>
           <a:solidFill>
-            <a:srgbClr val="F8F6F2"/>
+            <a:srgbClr val="F4F5F7"/>
           </a:solidFill>
           <a:ln w="12700">
             <a:solidFill>
@@ -13470,7 +13495,7 @@
             <a:r>
               <a:rPr lang="en-US" sz="3600" b="1" dirty="0">
                 <a:solidFill>
-                  <a:srgbClr val="B85042"/>
+                  <a:srgbClr val="6B7280"/>
                 </a:solidFill>
                 <a:latin typeface="Calibri" pitchFamily="34" charset="0"/>
                 <a:ea typeface="Calibri" pitchFamily="34" charset="-122"/>
@@ -13536,7 +13561,7 @@
             <a:avLst/>
           </a:prstGeom>
           <a:solidFill>
-            <a:srgbClr val="F8F6F2"/>
+            <a:srgbClr val="F4F5F7"/>
           </a:solidFill>
           <a:ln w="12700">
             <a:solidFill>
@@ -13573,7 +13598,7 @@
             <a:r>
               <a:rPr lang="en-US" sz="3600" b="1" dirty="0">
                 <a:solidFill>
-                  <a:srgbClr val="B85042"/>
+                  <a:srgbClr val="6B7280"/>
                 </a:solidFill>
                 <a:latin typeface="Calibri" pitchFamily="34" charset="0"/>
                 <a:ea typeface="Calibri" pitchFamily="34" charset="-122"/>
@@ -13651,7 +13676,7 @@
             <a:r>
               <a:rPr lang="en-US" sz="1000" dirty="0">
                 <a:solidFill>
-                  <a:srgbClr val="888888"/>
+                  <a:srgbClr val="6B7280"/>
                 </a:solidFill>
                 <a:latin typeface="Calibri" pitchFamily="34" charset="0"/>
                 <a:ea typeface="Calibri" pitchFamily="34" charset="-122"/>
@@ -13690,7 +13715,7 @@
             <a:r>
               <a:rPr lang="en-US" sz="1000" dirty="0">
                 <a:solidFill>
-                  <a:srgbClr val="888888"/>
+                  <a:srgbClr val="6B7280"/>
                 </a:solidFill>
                 <a:latin typeface="Calibri" pitchFamily="34" charset="0"/>
                 <a:ea typeface="Calibri" pitchFamily="34" charset="-122"/>
@@ -13749,11 +13774,11 @@
             <a:avLst/>
           </a:prstGeom>
           <a:solidFill>
-            <a:srgbClr val="B85042"/>
+            <a:srgbClr val="6B7280"/>
           </a:solidFill>
           <a:ln w="12700">
             <a:solidFill>
-              <a:srgbClr val="B85042"/>
+              <a:srgbClr val="6B7280"/>
             </a:solidFill>
             <a:prstDash val="solid"/>
           </a:ln>
@@ -13786,7 +13811,7 @@
             <a:r>
               <a:rPr lang="en-US" sz="1400" b="1" spc="400" kern="0" dirty="0">
                 <a:solidFill>
-                  <a:srgbClr val="B85042"/>
+                  <a:srgbClr val="6B7280"/>
                 </a:solidFill>
                 <a:latin typeface="Calibri" pitchFamily="34" charset="0"/>
                 <a:ea typeface="Calibri" pitchFamily="34" charset="-122"/>
@@ -13825,7 +13850,7 @@
             <a:r>
               <a:rPr lang="en-US" sz="4000" b="1" dirty="0">
                 <a:solidFill>
-                  <a:srgbClr val="1E2761"/>
+                  <a:srgbClr val="1E3A5F"/>
                 </a:solidFill>
                 <a:latin typeface="Calibri" pitchFamily="34" charset="0"/>
                 <a:ea typeface="Calibri" pitchFamily="34" charset="-122"/>
@@ -13864,7 +13889,7 @@
             <a:r>
               <a:rPr lang="en-US" sz="2200" b="1" dirty="0">
                 <a:solidFill>
-                  <a:srgbClr val="1E2761"/>
+                  <a:srgbClr val="1E3A5F"/>
                 </a:solidFill>
                 <a:latin typeface="Calibri" pitchFamily="34" charset="0"/>
                 <a:ea typeface="Calibri" pitchFamily="34" charset="-122"/>
@@ -14137,7 +14162,7 @@
             <a:r>
               <a:rPr lang="en-US" sz="2200" b="1" dirty="0">
                 <a:solidFill>
-                  <a:srgbClr val="1E2761"/>
+                  <a:srgbClr val="1E3A5F"/>
                 </a:solidFill>
                 <a:latin typeface="Calibri" pitchFamily="34" charset="0"/>
                 <a:ea typeface="Calibri" pitchFamily="34" charset="-122"/>
@@ -14176,7 +14201,7 @@
             <a:r>
               <a:rPr lang="en-US" sz="1400" b="1" dirty="0">
                 <a:solidFill>
-                  <a:srgbClr val="B85042"/>
+                  <a:srgbClr val="6B7280"/>
                 </a:solidFill>
                 <a:latin typeface="Calibri" pitchFamily="34" charset="0"/>
                 <a:ea typeface="Calibri" pitchFamily="34" charset="-122"/>
@@ -14254,7 +14279,7 @@
             <a:r>
               <a:rPr lang="en-US" sz="1400" b="1" dirty="0">
                 <a:solidFill>
-                  <a:srgbClr val="B85042"/>
+                  <a:srgbClr val="6B7280"/>
                 </a:solidFill>
                 <a:latin typeface="Calibri" pitchFamily="34" charset="0"/>
                 <a:ea typeface="Calibri" pitchFamily="34" charset="-122"/>
@@ -14332,7 +14357,7 @@
             <a:r>
               <a:rPr lang="en-US" sz="1400" b="1" dirty="0">
                 <a:solidFill>
-                  <a:srgbClr val="B85042"/>
+                  <a:srgbClr val="6B7280"/>
                 </a:solidFill>
                 <a:latin typeface="Calibri" pitchFamily="34" charset="0"/>
                 <a:ea typeface="Calibri" pitchFamily="34" charset="-122"/>
@@ -14410,7 +14435,7 @@
             <a:r>
               <a:rPr lang="en-US" sz="1400" b="1" dirty="0">
                 <a:solidFill>
-                  <a:srgbClr val="B85042"/>
+                  <a:srgbClr val="6B7280"/>
                 </a:solidFill>
                 <a:latin typeface="Calibri" pitchFamily="34" charset="0"/>
                 <a:ea typeface="Calibri" pitchFamily="34" charset="-122"/>
@@ -14488,7 +14513,7 @@
             <a:r>
               <a:rPr lang="en-US" sz="1400" b="1" dirty="0">
                 <a:solidFill>
-                  <a:srgbClr val="B85042"/>
+                  <a:srgbClr val="6B7280"/>
                 </a:solidFill>
                 <a:latin typeface="Calibri" pitchFamily="34" charset="0"/>
                 <a:ea typeface="Calibri" pitchFamily="34" charset="-122"/>
@@ -14566,7 +14591,7 @@
             <a:r>
               <a:rPr lang="en-US" sz="1400" b="1" dirty="0">
                 <a:solidFill>
-                  <a:srgbClr val="B85042"/>
+                  <a:srgbClr val="6B7280"/>
                 </a:solidFill>
                 <a:latin typeface="Calibri" pitchFamily="34" charset="0"/>
                 <a:ea typeface="Calibri" pitchFamily="34" charset="-122"/>
@@ -14644,7 +14669,7 @@
             <a:r>
               <a:rPr lang="en-US" sz="1000" dirty="0">
                 <a:solidFill>
-                  <a:srgbClr val="888888"/>
+                  <a:srgbClr val="6B7280"/>
                 </a:solidFill>
                 <a:latin typeface="Calibri" pitchFamily="34" charset="0"/>
                 <a:ea typeface="Calibri" pitchFamily="34" charset="-122"/>
@@ -14683,7 +14708,7 @@
             <a:r>
               <a:rPr lang="en-US" sz="1000" dirty="0">
                 <a:solidFill>
-                  <a:srgbClr val="888888"/>
+                  <a:srgbClr val="6B7280"/>
                 </a:solidFill>
                 <a:latin typeface="Calibri" pitchFamily="34" charset="0"/>
                 <a:ea typeface="Calibri" pitchFamily="34" charset="-122"/>
@@ -14709,7 +14734,7 @@
     <p:bg>
       <p:bgPr>
         <a:solidFill>
-          <a:srgbClr val="1E2761"/>
+          <a:srgbClr val="FFFFFF"/>
         </a:solidFill>
       </p:bgPr>
     </p:bg>
@@ -14736,17 +14761,17 @@
         <p:spPr>
           <a:xfrm>
             <a:off x="0" y="0"/>
-            <a:ext cx="365760" cy="6858000"/>
+            <a:ext cx="109728" cy="6858000"/>
           </a:xfrm>
           <a:prstGeom prst="rect">
             <a:avLst/>
           </a:prstGeom>
           <a:solidFill>
-            <a:srgbClr val="B85042"/>
+            <a:srgbClr val="6B7280"/>
           </a:solidFill>
           <a:ln w="12700">
             <a:solidFill>
-              <a:srgbClr val="B85042"/>
+              <a:srgbClr val="6B7280"/>
             </a:solidFill>
             <a:prstDash val="solid"/>
           </a:ln>
@@ -14779,7 +14804,7 @@
             <a:r>
               <a:rPr lang="en-US" sz="1600" b="1" spc="400" kern="0" dirty="0">
                 <a:solidFill>
-                  <a:srgbClr val="CADCFC"/>
+                  <a:srgbClr val="6B7280"/>
                 </a:solidFill>
                 <a:latin typeface="Calibri" pitchFamily="34" charset="0"/>
                 <a:ea typeface="Calibri" pitchFamily="34" charset="-122"/>
@@ -14818,7 +14843,7 @@
             <a:r>
               <a:rPr lang="en-US" sz="4400" b="1" dirty="0">
                 <a:solidFill>
-                  <a:srgbClr val="FFFFFF"/>
+                  <a:srgbClr val="1E3A5F"/>
                 </a:solidFill>
                 <a:latin typeface="Calibri" pitchFamily="34" charset="0"/>
                 <a:ea typeface="Calibri" pitchFamily="34" charset="-122"/>
@@ -14857,7 +14882,7 @@
             <a:r>
               <a:rPr lang="en-US" sz="1800" i="1" dirty="0">
                 <a:solidFill>
-                  <a:srgbClr val="CADCFC"/>
+                  <a:srgbClr val="6B7280"/>
                 </a:solidFill>
                 <a:latin typeface="Calibri" pitchFamily="34" charset="0"/>
                 <a:ea typeface="Calibri" pitchFamily="34" charset="-122"/>
@@ -14884,11 +14909,11 @@
             <a:avLst/>
           </a:prstGeom>
           <a:solidFill>
-            <a:srgbClr val="0F1737"/>
+            <a:srgbClr val="F4F5F7"/>
           </a:solidFill>
           <a:ln w="12700">
             <a:solidFill>
-              <a:srgbClr val="B85042"/>
+              <a:srgbClr val="D1D5DB"/>
             </a:solidFill>
             <a:prstDash val="solid"/>
           </a:ln>
@@ -14921,7 +14946,7 @@
             <a:r>
               <a:rPr lang="en-US" sz="1300" b="1" dirty="0">
                 <a:solidFill>
-                  <a:srgbClr val="B85042"/>
+                  <a:srgbClr val="6B7280"/>
                 </a:solidFill>
                 <a:latin typeface="Calibri" pitchFamily="34" charset="0"/>
                 <a:ea typeface="Calibri" pitchFamily="34" charset="-122"/>
@@ -14960,7 +14985,7 @@
             <a:r>
               <a:rPr lang="en-US" sz="1600" b="1" dirty="0">
                 <a:solidFill>
-                  <a:srgbClr val="FFFFFF"/>
+                  <a:srgbClr val="1E3A5F"/>
                 </a:solidFill>
                 <a:latin typeface="Calibri" pitchFamily="34" charset="0"/>
                 <a:ea typeface="Calibri" pitchFamily="34" charset="-122"/>
@@ -14987,11 +15012,11 @@
             <a:avLst/>
           </a:prstGeom>
           <a:solidFill>
-            <a:srgbClr val="0F1737"/>
+            <a:srgbClr val="F4F5F7"/>
           </a:solidFill>
           <a:ln w="12700">
             <a:solidFill>
-              <a:srgbClr val="B85042"/>
+              <a:srgbClr val="D1D5DB"/>
             </a:solidFill>
             <a:prstDash val="solid"/>
           </a:ln>
@@ -15024,7 +15049,7 @@
             <a:r>
               <a:rPr lang="en-US" sz="1300" b="1" dirty="0">
                 <a:solidFill>
-                  <a:srgbClr val="B85042"/>
+                  <a:srgbClr val="6B7280"/>
                 </a:solidFill>
                 <a:latin typeface="Calibri" pitchFamily="34" charset="0"/>
                 <a:ea typeface="Calibri" pitchFamily="34" charset="-122"/>
@@ -15063,7 +15088,7 @@
             <a:r>
               <a:rPr lang="en-US" sz="1600" b="1" dirty="0">
                 <a:solidFill>
-                  <a:srgbClr val="FFFFFF"/>
+                  <a:srgbClr val="1E3A5F"/>
                 </a:solidFill>
                 <a:latin typeface="Calibri" pitchFamily="34" charset="0"/>
                 <a:ea typeface="Calibri" pitchFamily="34" charset="-122"/>
@@ -15090,11 +15115,11 @@
             <a:avLst/>
           </a:prstGeom>
           <a:solidFill>
-            <a:srgbClr val="0F1737"/>
+            <a:srgbClr val="F4F5F7"/>
           </a:solidFill>
           <a:ln w="12700">
             <a:solidFill>
-              <a:srgbClr val="B85042"/>
+              <a:srgbClr val="D1D5DB"/>
             </a:solidFill>
             <a:prstDash val="solid"/>
           </a:ln>
@@ -15127,7 +15152,7 @@
             <a:r>
               <a:rPr lang="en-US" sz="1300" b="1" dirty="0">
                 <a:solidFill>
-                  <a:srgbClr val="B85042"/>
+                  <a:srgbClr val="6B7280"/>
                 </a:solidFill>
                 <a:latin typeface="Calibri" pitchFamily="34" charset="0"/>
                 <a:ea typeface="Calibri" pitchFamily="34" charset="-122"/>
@@ -15166,7 +15191,7 @@
             <a:r>
               <a:rPr lang="en-US" sz="1600" b="1" dirty="0">
                 <a:solidFill>
-                  <a:srgbClr val="FFFFFF"/>
+                  <a:srgbClr val="1E3A5F"/>
                 </a:solidFill>
                 <a:latin typeface="Calibri" pitchFamily="34" charset="0"/>
                 <a:ea typeface="Calibri" pitchFamily="34" charset="-122"/>
@@ -15205,7 +15230,7 @@
             <a:r>
               <a:rPr lang="en-US" sz="1200" i="1" dirty="0">
                 <a:solidFill>
-                  <a:srgbClr val="CADCFC"/>
+                  <a:srgbClr val="6B7280"/>
                 </a:solidFill>
                 <a:latin typeface="Calibri" pitchFamily="34" charset="0"/>
                 <a:ea typeface="Calibri" pitchFamily="34" charset="-122"/>
@@ -15264,11 +15289,11 @@
             <a:avLst/>
           </a:prstGeom>
           <a:solidFill>
-            <a:srgbClr val="B85042"/>
+            <a:srgbClr val="6B7280"/>
           </a:solidFill>
           <a:ln w="12700">
             <a:solidFill>
-              <a:srgbClr val="B85042"/>
+              <a:srgbClr val="6B7280"/>
             </a:solidFill>
             <a:prstDash val="solid"/>
           </a:ln>
@@ -15301,7 +15326,7 @@
             <a:r>
               <a:rPr lang="en-US" sz="1400" b="1" spc="400" kern="0" dirty="0">
                 <a:solidFill>
-                  <a:srgbClr val="B85042"/>
+                  <a:srgbClr val="6B7280"/>
                 </a:solidFill>
                 <a:latin typeface="Calibri" pitchFamily="34" charset="0"/>
                 <a:ea typeface="Calibri" pitchFamily="34" charset="-122"/>
@@ -15340,7 +15365,7 @@
             <a:r>
               <a:rPr lang="en-US" sz="4000" b="1" dirty="0">
                 <a:solidFill>
-                  <a:srgbClr val="1E2761"/>
+                  <a:srgbClr val="1E3A5F"/>
                 </a:solidFill>
                 <a:latin typeface="Calibri" pitchFamily="34" charset="0"/>
                 <a:ea typeface="Calibri" pitchFamily="34" charset="-122"/>
@@ -15367,11 +15392,11 @@
             <a:avLst/>
           </a:prstGeom>
           <a:solidFill>
-            <a:srgbClr val="B85042"/>
+            <a:srgbClr val="6B7280"/>
           </a:solidFill>
           <a:ln w="12700">
             <a:solidFill>
-              <a:srgbClr val="B85042"/>
+              <a:srgbClr val="6B7280"/>
             </a:solidFill>
             <a:prstDash val="solid"/>
           </a:ln>
@@ -15431,7 +15456,7 @@
             <a:avLst/>
           </a:prstGeom>
           <a:solidFill>
-            <a:srgbClr val="F8F6F2"/>
+            <a:srgbClr val="F4F5F7"/>
           </a:solidFill>
           <a:ln w="12700">
             <a:solidFill>
@@ -15468,7 +15493,7 @@
             <a:r>
               <a:rPr lang="en-US" sz="1800" b="1" dirty="0">
                 <a:solidFill>
-                  <a:srgbClr val="1E2761"/>
+                  <a:srgbClr val="1E3A5F"/>
                 </a:solidFill>
                 <a:latin typeface="Calibri" pitchFamily="34" charset="0"/>
                 <a:ea typeface="Calibri" pitchFamily="34" charset="-122"/>
@@ -15507,7 +15532,7 @@
             <a:r>
               <a:rPr lang="en-US" sz="1300" i="1" dirty="0">
                 <a:solidFill>
-                  <a:srgbClr val="B85042"/>
+                  <a:srgbClr val="6B7280"/>
                 </a:solidFill>
                 <a:latin typeface="Calibri" pitchFamily="34" charset="0"/>
                 <a:ea typeface="Calibri" pitchFamily="34" charset="-122"/>
@@ -15573,11 +15598,11 @@
             <a:avLst/>
           </a:prstGeom>
           <a:solidFill>
-            <a:srgbClr val="B85042"/>
+            <a:srgbClr val="6B7280"/>
           </a:solidFill>
           <a:ln w="12700">
             <a:solidFill>
-              <a:srgbClr val="B85042"/>
+              <a:srgbClr val="6B7280"/>
             </a:solidFill>
             <a:prstDash val="solid"/>
           </a:ln>
@@ -15637,7 +15662,7 @@
             <a:avLst/>
           </a:prstGeom>
           <a:solidFill>
-            <a:srgbClr val="F8F6F2"/>
+            <a:srgbClr val="F4F5F7"/>
           </a:solidFill>
           <a:ln w="12700">
             <a:solidFill>
@@ -15674,7 +15699,7 @@
             <a:r>
               <a:rPr lang="en-US" sz="1800" b="1" dirty="0">
                 <a:solidFill>
-                  <a:srgbClr val="1E2761"/>
+                  <a:srgbClr val="1E3A5F"/>
                 </a:solidFill>
                 <a:latin typeface="Calibri" pitchFamily="34" charset="0"/>
                 <a:ea typeface="Calibri" pitchFamily="34" charset="-122"/>
@@ -15713,7 +15738,7 @@
             <a:r>
               <a:rPr lang="en-US" sz="1300" i="1" dirty="0">
                 <a:solidFill>
-                  <a:srgbClr val="B85042"/>
+                  <a:srgbClr val="6B7280"/>
                 </a:solidFill>
                 <a:latin typeface="Calibri" pitchFamily="34" charset="0"/>
                 <a:ea typeface="Calibri" pitchFamily="34" charset="-122"/>
@@ -15779,11 +15804,11 @@
             <a:avLst/>
           </a:prstGeom>
           <a:solidFill>
-            <a:srgbClr val="B85042"/>
+            <a:srgbClr val="6B7280"/>
           </a:solidFill>
           <a:ln w="12700">
             <a:solidFill>
-              <a:srgbClr val="B85042"/>
+              <a:srgbClr val="6B7280"/>
             </a:solidFill>
             <a:prstDash val="solid"/>
           </a:ln>
@@ -15843,7 +15868,7 @@
             <a:avLst/>
           </a:prstGeom>
           <a:solidFill>
-            <a:srgbClr val="F8F6F2"/>
+            <a:srgbClr val="F4F5F7"/>
           </a:solidFill>
           <a:ln w="12700">
             <a:solidFill>
@@ -15880,7 +15905,7 @@
             <a:r>
               <a:rPr lang="en-US" sz="1800" b="1" dirty="0">
                 <a:solidFill>
-                  <a:srgbClr val="1E2761"/>
+                  <a:srgbClr val="1E3A5F"/>
                 </a:solidFill>
                 <a:latin typeface="Calibri" pitchFamily="34" charset="0"/>
                 <a:ea typeface="Calibri" pitchFamily="34" charset="-122"/>
@@ -15919,7 +15944,7 @@
             <a:r>
               <a:rPr lang="en-US" sz="1300" i="1" dirty="0">
                 <a:solidFill>
-                  <a:srgbClr val="B85042"/>
+                  <a:srgbClr val="6B7280"/>
                 </a:solidFill>
                 <a:latin typeface="Calibri" pitchFamily="34" charset="0"/>
                 <a:ea typeface="Calibri" pitchFamily="34" charset="-122"/>
@@ -15997,7 +16022,7 @@
             <a:r>
               <a:rPr lang="en-US" sz="1000" dirty="0">
                 <a:solidFill>
-                  <a:srgbClr val="888888"/>
+                  <a:srgbClr val="6B7280"/>
                 </a:solidFill>
                 <a:latin typeface="Calibri" pitchFamily="34" charset="0"/>
                 <a:ea typeface="Calibri" pitchFamily="34" charset="-122"/>
@@ -16023,7 +16048,7 @@
     <p:bg>
       <p:bgPr>
         <a:solidFill>
-          <a:srgbClr val="1E2761"/>
+          <a:srgbClr val="FFFFFF"/>
         </a:solidFill>
       </p:bgPr>
     </p:bg>
@@ -16050,17 +16075,17 @@
         <p:spPr>
           <a:xfrm>
             <a:off x="0" y="0"/>
-            <a:ext cx="365760" cy="6858000"/>
+            <a:ext cx="109728" cy="6858000"/>
           </a:xfrm>
           <a:prstGeom prst="rect">
             <a:avLst/>
           </a:prstGeom>
           <a:solidFill>
-            <a:srgbClr val="B85042"/>
+            <a:srgbClr val="6B7280"/>
           </a:solidFill>
           <a:ln w="12700">
             <a:solidFill>
-              <a:srgbClr val="B85042"/>
+              <a:srgbClr val="6B7280"/>
             </a:solidFill>
             <a:prstDash val="solid"/>
           </a:ln>
@@ -16093,7 +16118,7 @@
             <a:r>
               <a:rPr lang="en-US" sz="1600" b="1" spc="400" kern="0" dirty="0">
                 <a:solidFill>
-                  <a:srgbClr val="CADCFC"/>
+                  <a:srgbClr val="6B7280"/>
                 </a:solidFill>
                 <a:latin typeface="Calibri" pitchFamily="34" charset="0"/>
                 <a:ea typeface="Calibri" pitchFamily="34" charset="-122"/>
@@ -16132,7 +16157,7 @@
             <a:r>
               <a:rPr lang="en-US" sz="4400" b="1" dirty="0">
                 <a:solidFill>
-                  <a:srgbClr val="FFFFFF"/>
+                  <a:srgbClr val="1E3A5F"/>
                 </a:solidFill>
                 <a:latin typeface="Calibri" pitchFamily="34" charset="0"/>
                 <a:ea typeface="Calibri" pitchFamily="34" charset="-122"/>
@@ -16171,7 +16196,7 @@
             <a:r>
               <a:rPr lang="en-US" sz="1800" i="1" dirty="0">
                 <a:solidFill>
-                  <a:srgbClr val="CADCFC"/>
+                  <a:srgbClr val="6B7280"/>
                 </a:solidFill>
                 <a:latin typeface="Calibri" pitchFamily="34" charset="0"/>
                 <a:ea typeface="Calibri" pitchFamily="34" charset="-122"/>
@@ -16198,11 +16223,11 @@
             <a:avLst/>
           </a:prstGeom>
           <a:solidFill>
-            <a:srgbClr val="0F1737"/>
+            <a:srgbClr val="F4F5F7"/>
           </a:solidFill>
           <a:ln w="12700">
             <a:solidFill>
-              <a:srgbClr val="B85042"/>
+              <a:srgbClr val="D1D5DB"/>
             </a:solidFill>
             <a:prstDash val="solid"/>
           </a:ln>
@@ -16235,7 +16260,7 @@
             <a:r>
               <a:rPr lang="en-US" sz="1300" b="1" dirty="0">
                 <a:solidFill>
-                  <a:srgbClr val="B85042"/>
+                  <a:srgbClr val="6B7280"/>
                 </a:solidFill>
                 <a:latin typeface="Calibri" pitchFamily="34" charset="0"/>
                 <a:ea typeface="Calibri" pitchFamily="34" charset="-122"/>
@@ -16274,7 +16299,7 @@
             <a:r>
               <a:rPr lang="en-US" sz="1600" b="1" dirty="0">
                 <a:solidFill>
-                  <a:srgbClr val="FFFFFF"/>
+                  <a:srgbClr val="1E3A5F"/>
                 </a:solidFill>
                 <a:latin typeface="Calibri" pitchFamily="34" charset="0"/>
                 <a:ea typeface="Calibri" pitchFamily="34" charset="-122"/>
@@ -16301,11 +16326,11 @@
             <a:avLst/>
           </a:prstGeom>
           <a:solidFill>
-            <a:srgbClr val="0F1737"/>
+            <a:srgbClr val="F4F5F7"/>
           </a:solidFill>
           <a:ln w="12700">
             <a:solidFill>
-              <a:srgbClr val="B85042"/>
+              <a:srgbClr val="D1D5DB"/>
             </a:solidFill>
             <a:prstDash val="solid"/>
           </a:ln>
@@ -16338,7 +16363,7 @@
             <a:r>
               <a:rPr lang="en-US" sz="1300" b="1" dirty="0">
                 <a:solidFill>
-                  <a:srgbClr val="B85042"/>
+                  <a:srgbClr val="6B7280"/>
                 </a:solidFill>
                 <a:latin typeface="Calibri" pitchFamily="34" charset="0"/>
                 <a:ea typeface="Calibri" pitchFamily="34" charset="-122"/>
@@ -16377,7 +16402,7 @@
             <a:r>
               <a:rPr lang="en-US" sz="1600" b="1" dirty="0">
                 <a:solidFill>
-                  <a:srgbClr val="FFFFFF"/>
+                  <a:srgbClr val="1E3A5F"/>
                 </a:solidFill>
                 <a:latin typeface="Calibri" pitchFamily="34" charset="0"/>
                 <a:ea typeface="Calibri" pitchFamily="34" charset="-122"/>
@@ -16404,11 +16429,11 @@
             <a:avLst/>
           </a:prstGeom>
           <a:solidFill>
-            <a:srgbClr val="0F1737"/>
+            <a:srgbClr val="F4F5F7"/>
           </a:solidFill>
           <a:ln w="12700">
             <a:solidFill>
-              <a:srgbClr val="B85042"/>
+              <a:srgbClr val="D1D5DB"/>
             </a:solidFill>
             <a:prstDash val="solid"/>
           </a:ln>
@@ -16441,7 +16466,7 @@
             <a:r>
               <a:rPr lang="en-US" sz="1300" b="1" dirty="0">
                 <a:solidFill>
-                  <a:srgbClr val="B85042"/>
+                  <a:srgbClr val="6B7280"/>
                 </a:solidFill>
                 <a:latin typeface="Calibri" pitchFamily="34" charset="0"/>
                 <a:ea typeface="Calibri" pitchFamily="34" charset="-122"/>
@@ -16480,7 +16505,7 @@
             <a:r>
               <a:rPr lang="en-US" sz="1600" b="1" dirty="0">
                 <a:solidFill>
-                  <a:srgbClr val="FFFFFF"/>
+                  <a:srgbClr val="1E3A5F"/>
                 </a:solidFill>
                 <a:latin typeface="Calibri" pitchFamily="34" charset="0"/>
                 <a:ea typeface="Calibri" pitchFamily="34" charset="-122"/>
@@ -16519,7 +16544,7 @@
             <a:r>
               <a:rPr lang="en-US" sz="1200" i="1" dirty="0">
                 <a:solidFill>
-                  <a:srgbClr val="CADCFC"/>
+                  <a:srgbClr val="6B7280"/>
                 </a:solidFill>
                 <a:latin typeface="Calibri" pitchFamily="34" charset="0"/>
                 <a:ea typeface="Calibri" pitchFamily="34" charset="-122"/>
@@ -16578,11 +16603,11 @@
             <a:avLst/>
           </a:prstGeom>
           <a:solidFill>
-            <a:srgbClr val="B85042"/>
+            <a:srgbClr val="6B7280"/>
           </a:solidFill>
           <a:ln w="12700">
             <a:solidFill>
-              <a:srgbClr val="B85042"/>
+              <a:srgbClr val="6B7280"/>
             </a:solidFill>
             <a:prstDash val="solid"/>
           </a:ln>
@@ -16615,7 +16640,7 @@
             <a:r>
               <a:rPr lang="en-US" sz="1400" b="1" spc="400" kern="0" dirty="0">
                 <a:solidFill>
-                  <a:srgbClr val="B85042"/>
+                  <a:srgbClr val="6B7280"/>
                 </a:solidFill>
                 <a:latin typeface="Calibri" pitchFamily="34" charset="0"/>
                 <a:ea typeface="Calibri" pitchFamily="34" charset="-122"/>
@@ -16654,7 +16679,7 @@
             <a:r>
               <a:rPr lang="en-US" sz="4000" b="1" dirty="0">
                 <a:solidFill>
-                  <a:srgbClr val="1E2761"/>
+                  <a:srgbClr val="1E3A5F"/>
                 </a:solidFill>
                 <a:latin typeface="Calibri" pitchFamily="34" charset="0"/>
                 <a:ea typeface="Calibri" pitchFamily="34" charset="-122"/>
@@ -16681,11 +16706,11 @@
             <a:avLst/>
           </a:prstGeom>
           <a:solidFill>
-            <a:srgbClr val="B85042"/>
+            <a:srgbClr val="6B7280"/>
           </a:solidFill>
           <a:ln w="12700">
             <a:solidFill>
-              <a:srgbClr val="B85042"/>
+              <a:srgbClr val="6B7280"/>
             </a:solidFill>
             <a:prstDash val="solid"/>
           </a:ln>
@@ -16745,7 +16770,7 @@
             <a:avLst/>
           </a:prstGeom>
           <a:solidFill>
-            <a:srgbClr val="F8F6F2"/>
+            <a:srgbClr val="F4F5F7"/>
           </a:solidFill>
           <a:ln w="12700">
             <a:solidFill>
@@ -16782,7 +16807,7 @@
             <a:r>
               <a:rPr lang="en-US" sz="1800" b="1" dirty="0">
                 <a:solidFill>
-                  <a:srgbClr val="1E2761"/>
+                  <a:srgbClr val="1E3A5F"/>
                 </a:solidFill>
                 <a:latin typeface="Calibri" pitchFamily="34" charset="0"/>
                 <a:ea typeface="Calibri" pitchFamily="34" charset="-122"/>
@@ -16821,7 +16846,7 @@
             <a:r>
               <a:rPr lang="en-US" sz="1300" i="1" dirty="0">
                 <a:solidFill>
-                  <a:srgbClr val="B85042"/>
+                  <a:srgbClr val="6B7280"/>
                 </a:solidFill>
                 <a:latin typeface="Calibri" pitchFamily="34" charset="0"/>
                 <a:ea typeface="Calibri" pitchFamily="34" charset="-122"/>
@@ -16887,11 +16912,11 @@
             <a:avLst/>
           </a:prstGeom>
           <a:solidFill>
-            <a:srgbClr val="B85042"/>
+            <a:srgbClr val="6B7280"/>
           </a:solidFill>
           <a:ln w="12700">
             <a:solidFill>
-              <a:srgbClr val="B85042"/>
+              <a:srgbClr val="6B7280"/>
             </a:solidFill>
             <a:prstDash val="solid"/>
           </a:ln>
@@ -16951,7 +16976,7 @@
             <a:avLst/>
           </a:prstGeom>
           <a:solidFill>
-            <a:srgbClr val="F8F6F2"/>
+            <a:srgbClr val="F4F5F7"/>
           </a:solidFill>
           <a:ln w="12700">
             <a:solidFill>
@@ -16988,7 +17013,7 @@
             <a:r>
               <a:rPr lang="en-US" sz="1800" b="1" dirty="0">
                 <a:solidFill>
-                  <a:srgbClr val="1E2761"/>
+                  <a:srgbClr val="1E3A5F"/>
                 </a:solidFill>
                 <a:latin typeface="Calibri" pitchFamily="34" charset="0"/>
                 <a:ea typeface="Calibri" pitchFamily="34" charset="-122"/>
@@ -17027,7 +17052,7 @@
             <a:r>
               <a:rPr lang="en-US" sz="1300" i="1" dirty="0">
                 <a:solidFill>
-                  <a:srgbClr val="B85042"/>
+                  <a:srgbClr val="6B7280"/>
                 </a:solidFill>
                 <a:latin typeface="Calibri" pitchFamily="34" charset="0"/>
                 <a:ea typeface="Calibri" pitchFamily="34" charset="-122"/>
@@ -17093,11 +17118,11 @@
             <a:avLst/>
           </a:prstGeom>
           <a:solidFill>
-            <a:srgbClr val="B85042"/>
+            <a:srgbClr val="6B7280"/>
           </a:solidFill>
           <a:ln w="12700">
             <a:solidFill>
-              <a:srgbClr val="B85042"/>
+              <a:srgbClr val="6B7280"/>
             </a:solidFill>
             <a:prstDash val="solid"/>
           </a:ln>
@@ -17157,7 +17182,7 @@
             <a:avLst/>
           </a:prstGeom>
           <a:solidFill>
-            <a:srgbClr val="F8F6F2"/>
+            <a:srgbClr val="F4F5F7"/>
           </a:solidFill>
           <a:ln w="12700">
             <a:solidFill>
@@ -17194,7 +17219,7 @@
             <a:r>
               <a:rPr lang="en-US" sz="1800" b="1" dirty="0">
                 <a:solidFill>
-                  <a:srgbClr val="1E2761"/>
+                  <a:srgbClr val="1E3A5F"/>
                 </a:solidFill>
                 <a:latin typeface="Calibri" pitchFamily="34" charset="0"/>
                 <a:ea typeface="Calibri" pitchFamily="34" charset="-122"/>
@@ -17233,7 +17258,7 @@
             <a:r>
               <a:rPr lang="en-US" sz="1300" i="1" dirty="0">
                 <a:solidFill>
-                  <a:srgbClr val="B85042"/>
+                  <a:srgbClr val="6B7280"/>
                 </a:solidFill>
                 <a:latin typeface="Calibri" pitchFamily="34" charset="0"/>
                 <a:ea typeface="Calibri" pitchFamily="34" charset="-122"/>
@@ -17311,7 +17336,7 @@
             <a:r>
               <a:rPr lang="en-US" sz="1000" dirty="0">
                 <a:solidFill>
-                  <a:srgbClr val="888888"/>
+                  <a:srgbClr val="6B7280"/>
                 </a:solidFill>
                 <a:latin typeface="Calibri" pitchFamily="34" charset="0"/>
                 <a:ea typeface="Calibri" pitchFamily="34" charset="-122"/>

</xml_diff>

<commit_message>
rebrand: FC docs — strip "USMC Ministries · usmcmin.org" credits
Master.docx, Workbook.docx, Deck.pptx, Drills PDF, Task PDFs zip rebuilt with "Family Captain" wordmark/footer instead of "USMC Ministries · usmcmin.org". TFC gives MOOP a $850/mo discount; FC docs are appropriately Family Captain branded.
</commit_message>
<xml_diff>
--- a/downloads/family-captain/Family_Captain_Bootcamp_DECK.pptx
+++ b/downloads/family-captain/Family_Captain_Bootcamp_DECK.pptx
@@ -2919,7 +2919,7 @@
                 <a:ea typeface="Calibri" pitchFamily="34" charset="-122"/>
                 <a:cs typeface="Calibri" pitchFamily="34" charset="-120"/>
               </a:rPr>
-              <a:t>USMC Ministries · usmcmin.org</a:t>
+              <a:t>Family Captain</a:t>
             </a:r>
             <a:endParaRPr lang="en-US" sz="1400" dirty="0"/>
           </a:p>
@@ -4258,7 +4258,7 @@
                 <a:ea typeface="Calibri" pitchFamily="34" charset="-122"/>
                 <a:cs typeface="Calibri" pitchFamily="34" charset="-120"/>
               </a:rPr>
-              <a:t>USMC Ministries · usmcmin.org</a:t>
+              <a:t>Family Captain</a:t>
             </a:r>
             <a:endParaRPr lang="en-US" sz="1000" dirty="0"/>
           </a:p>
@@ -5572,7 +5572,7 @@
                 <a:ea typeface="Calibri" pitchFamily="34" charset="-122"/>
                 <a:cs typeface="Calibri" pitchFamily="34" charset="-120"/>
               </a:rPr>
-              <a:t>USMC Ministries · usmcmin.org</a:t>
+              <a:t>Family Captain</a:t>
             </a:r>
             <a:endParaRPr lang="en-US" sz="1000" dirty="0"/>
           </a:p>
@@ -6886,7 +6886,7 @@
                 <a:ea typeface="Calibri" pitchFamily="34" charset="-122"/>
                 <a:cs typeface="Calibri" pitchFamily="34" charset="-120"/>
               </a:rPr>
-              <a:t>USMC Ministries · usmcmin.org</a:t>
+              <a:t>Family Captain</a:t>
             </a:r>
             <a:endParaRPr lang="en-US" sz="1000" dirty="0"/>
           </a:p>
@@ -7500,7 +7500,7 @@
                 <a:ea typeface="Calibri" pitchFamily="34" charset="-122"/>
                 <a:cs typeface="Calibri" pitchFamily="34" charset="-120"/>
               </a:rPr>
-              <a:t>USMC Ministries · usmcmin.org</a:t>
+              <a:t>Family Captain</a:t>
             </a:r>
             <a:endParaRPr lang="en-US" sz="1000" dirty="0"/>
           </a:p>
@@ -8228,7 +8228,7 @@
                 <a:ea typeface="Calibri" pitchFamily="34" charset="-122"/>
                 <a:cs typeface="Calibri" pitchFamily="34" charset="-120"/>
               </a:rPr>
-              <a:t>USMC Ministries · usmcmin.org</a:t>
+              <a:t>Family Captain</a:t>
             </a:r>
             <a:endParaRPr lang="en-US" sz="1000" dirty="0"/>
           </a:p>
@@ -8814,7 +8814,7 @@
                 <a:ea typeface="Calibri" pitchFamily="34" charset="-122"/>
                 <a:cs typeface="Calibri" pitchFamily="34" charset="-120"/>
               </a:rPr>
-              <a:t>USMC Ministries · usmcmin.org</a:t>
+              <a:t>Family Captain</a:t>
             </a:r>
             <a:endParaRPr lang="en-US" sz="1000" dirty="0"/>
           </a:p>
@@ -9364,7 +9364,7 @@
                 <a:ea typeface="Calibri" pitchFamily="34" charset="-122"/>
                 <a:cs typeface="Calibri" pitchFamily="34" charset="-120"/>
               </a:rPr>
-              <a:t>USMC Ministries · usmcmin.org</a:t>
+              <a:t>Family Captain</a:t>
             </a:r>
             <a:endParaRPr lang="en-US" sz="1000" dirty="0"/>
           </a:p>
@@ -9950,7 +9950,7 @@
                 <a:ea typeface="Calibri" pitchFamily="34" charset="-122"/>
                 <a:cs typeface="Calibri" pitchFamily="34" charset="-120"/>
               </a:rPr>
-              <a:t>USMC Ministries · usmcmin.org</a:t>
+              <a:t>Family Captain</a:t>
             </a:r>
             <a:endParaRPr lang="en-US" sz="1000" dirty="0"/>
           </a:p>
@@ -10756,7 +10756,7 @@
                 <a:ea typeface="Calibri" pitchFamily="34" charset="-122"/>
                 <a:cs typeface="Calibri" pitchFamily="34" charset="-120"/>
               </a:rPr>
-              <a:t>USMC Ministries · usmcmin.org</a:t>
+              <a:t>Family Captain</a:t>
             </a:r>
             <a:endParaRPr lang="en-US" sz="1000" dirty="0"/>
           </a:p>
@@ -11452,7 +11452,7 @@
                 <a:ea typeface="Calibri" pitchFamily="34" charset="-122"/>
                 <a:cs typeface="Calibri" pitchFamily="34" charset="-120"/>
               </a:rPr>
-              <a:t>USMC Ministries · Family Captain · usmcmin.org</a:t>
+              <a:t>Family Captain</a:t>
             </a:r>
             <a:endParaRPr lang="en-US" sz="1400" dirty="0"/>
           </a:p>
@@ -12620,7 +12620,7 @@
                 <a:ea typeface="Calibri" pitchFamily="34" charset="-122"/>
                 <a:cs typeface="Calibri" pitchFamily="34" charset="-120"/>
               </a:rPr>
-              <a:t>USMC Ministries · usmcmin.org</a:t>
+              <a:t>Family Captain</a:t>
             </a:r>
             <a:endParaRPr lang="en-US" sz="1000" dirty="0"/>
           </a:p>
@@ -13682,7 +13682,7 @@
                 <a:ea typeface="Calibri" pitchFamily="34" charset="-122"/>
                 <a:cs typeface="Calibri" pitchFamily="34" charset="-120"/>
               </a:rPr>
-              <a:t>USMC Ministries · usmcmin.org</a:t>
+              <a:t>Family Captain</a:t>
             </a:r>
             <a:endParaRPr lang="en-US" sz="1000" dirty="0"/>
           </a:p>
@@ -14675,7 +14675,7 @@
                 <a:ea typeface="Calibri" pitchFamily="34" charset="-122"/>
                 <a:cs typeface="Calibri" pitchFamily="34" charset="-120"/>
               </a:rPr>
-              <a:t>USMC Ministries · usmcmin.org</a:t>
+              <a:t>Family Captain</a:t>
             </a:r>
             <a:endParaRPr lang="en-US" sz="1000" dirty="0"/>
           </a:p>
@@ -16028,7 +16028,7 @@
                 <a:ea typeface="Calibri" pitchFamily="34" charset="-122"/>
                 <a:cs typeface="Calibri" pitchFamily="34" charset="-120"/>
               </a:rPr>
-              <a:t>USMC Ministries · usmcmin.org</a:t>
+              <a:t>Family Captain</a:t>
             </a:r>
             <a:endParaRPr lang="en-US" sz="1000" dirty="0"/>
           </a:p>
@@ -17342,7 +17342,7 @@
                 <a:ea typeface="Calibri" pitchFamily="34" charset="-122"/>
                 <a:cs typeface="Calibri" pitchFamily="34" charset="-120"/>
               </a:rPr>
-              <a:t>USMC Ministries · usmcmin.org</a:t>
+              <a:t>Family Captain</a:t>
             </a:r>
             <a:endParaRPr lang="en-US" sz="1000" dirty="0"/>
           </a:p>

</xml_diff>

<commit_message>
Phase D.3.2: 7-week artifacts (Armada order) + heartbeat posts
Master/Workbook/Deck/Drills/zip regenerated in Armada order. New: Family_Captain_Heartbeat_Posts.md — 21 cohort drops (7 weeks x Mon Kickoff/Wed Check/Fri Sit). Scripture refs link to usmcmin.org/bible.html throughout.
</commit_message>
<xml_diff>
--- a/downloads/family-captain/Family_Captain_Bootcamp_DECK.pptx
+++ b/downloads/family-captain/Family_Captain_Bootcamp_DECK.pptx
@@ -4136,7 +4136,7 @@
                 <a:ea typeface="Calibri" pitchFamily="34" charset="-122"/>
                 <a:cs typeface="Calibri" pitchFamily="34" charset="-120"/>
               </a:rPr>
-              <a:t>Prep One Hard Conversation</a:t>
+              <a:t>Captain's Meal Plan</a:t>
             </a:r>
             <a:endParaRPr lang="en-US" sz="4000" dirty="0"/>
           </a:p>
@@ -4175,7 +4175,7 @@
                 <a:ea typeface="Calibri" pitchFamily="34" charset="-122"/>
                 <a:cs typeface="Calibri" pitchFamily="34" charset="-120"/>
               </a:rPr>
-              <a:t>AI prepares the captain. The captain shows up.</a:t>
+              <a:t>Protein-forward one-week plan. AI drafts. Shopper collaborates.</a:t>
             </a:r>
             <a:endParaRPr lang="en-US" sz="2000" dirty="0"/>
           </a:p>
@@ -4445,7 +4445,7 @@
                 <a:ea typeface="Calibri" pitchFamily="34" charset="-122"/>
                 <a:cs typeface="Calibri" pitchFamily="34" charset="-120"/>
               </a:rPr>
-              <a:t>Week 2 · Husbanding</a:t>
+              <a:t>Week 2 · Body</a:t>
             </a:r>
             <a:endParaRPr lang="en-US" sz="2200" dirty="0"/>
           </a:p>
@@ -4484,7 +4484,7 @@
                 <a:ea typeface="Calibri" pitchFamily="34" charset="-122"/>
                 <a:cs typeface="Calibri" pitchFamily="34" charset="-120"/>
               </a:rPr>
-              <a:t>Ephesians 5:25-28</a:t>
+              <a:t>1 Corinthians 6:19-20</a:t>
             </a:r>
             <a:endParaRPr lang="en-US" sz="1800" dirty="0"/>
           </a:p>
@@ -4562,7 +4562,7 @@
                 <a:ea typeface="Calibri" pitchFamily="34" charset="-122"/>
                 <a:cs typeface="Calibri" pitchFamily="34" charset="-120"/>
               </a:rPr>
-              <a:t>Week 2 · Husbanding · Task 2</a:t>
+              <a:t>Week 2 · Body · Task 2</a:t>
             </a:r>
             <a:endParaRPr lang="en-US" sz="1000" dirty="0"/>
           </a:p>
@@ -4700,7 +4700,7 @@
                 <a:ea typeface="Calibri" pitchFamily="34" charset="-122"/>
                 <a:cs typeface="Calibri" pitchFamily="34" charset="-120"/>
               </a:rPr>
-              <a:t>Letter to Your Wife</a:t>
+              <a:t>5-Night Sleep Audit</a:t>
             </a:r>
             <a:endParaRPr lang="en-US" sz="4000" dirty="0"/>
           </a:p>
@@ -4739,7 +4739,7 @@
                 <a:ea typeface="Calibri" pitchFamily="34" charset="-122"/>
                 <a:cs typeface="Calibri" pitchFamily="34" charset="-120"/>
               </a:rPr>
-              <a:t>One page. AI polishes grammar. You sign. You hand it over.</a:t>
+              <a:t>Log 5 nights. AI summarizes. Fix one variable next week.</a:t>
             </a:r>
             <a:endParaRPr lang="en-US" sz="2000" dirty="0"/>
           </a:p>
@@ -5009,7 +5009,7 @@
                 <a:ea typeface="Calibri" pitchFamily="34" charset="-122"/>
                 <a:cs typeface="Calibri" pitchFamily="34" charset="-120"/>
               </a:rPr>
-              <a:t>Week 2 · Husbanding</a:t>
+              <a:t>Week 2 · Body</a:t>
             </a:r>
             <a:endParaRPr lang="en-US" sz="2200" dirty="0"/>
           </a:p>
@@ -5048,7 +5048,7 @@
                 <a:ea typeface="Calibri" pitchFamily="34" charset="-122"/>
                 <a:cs typeface="Calibri" pitchFamily="34" charset="-120"/>
               </a:rPr>
-              <a:t>Ephesians 5:25-28</a:t>
+              <a:t>1 Corinthians 6:19-20</a:t>
             </a:r>
             <a:endParaRPr lang="en-US" sz="1800" dirty="0"/>
           </a:p>
@@ -5126,7 +5126,7 @@
                 <a:ea typeface="Calibri" pitchFamily="34" charset="-122"/>
                 <a:cs typeface="Calibri" pitchFamily="34" charset="-120"/>
               </a:rPr>
-              <a:t>Week 2 · Husbanding · Task 3</a:t>
+              <a:t>Week 2 · Body · Task 3</a:t>
             </a:r>
             <a:endParaRPr lang="en-US" sz="1000" dirty="0"/>
           </a:p>
@@ -5264,7 +5264,7 @@
                 <a:ea typeface="Calibri" pitchFamily="34" charset="-122"/>
                 <a:cs typeface="Calibri" pitchFamily="34" charset="-120"/>
               </a:rPr>
-              <a:t>FATHERING</a:t>
+              <a:t>SPIRITUAL</a:t>
             </a:r>
             <a:endParaRPr lang="en-US" sz="7200" dirty="0"/>
           </a:p>
@@ -5328,7 +5328,7 @@
                 <a:ea typeface="Calibri" pitchFamily="34" charset="-122"/>
                 <a:cs typeface="Calibri" pitchFamily="34" charset="-120"/>
               </a:rPr>
-              <a:t>Train up your children. AI assists; the captain disciples.</a:t>
+              <a:t>Walk with God. The captain's command flows from his communion.</a:t>
             </a:r>
             <a:endParaRPr lang="en-US" sz="2400" dirty="0"/>
           </a:p>
@@ -5406,7 +5406,7 @@
                 <a:ea typeface="Calibri" pitchFamily="34" charset="-122"/>
                 <a:cs typeface="Calibri" pitchFamily="34" charset="-120"/>
               </a:rPr>
-              <a:t>Deuteronomy 6:6-7</a:t>
+              <a:t>Joshua 1:8</a:t>
             </a:r>
             <a:endParaRPr lang="en-US" sz="2000" dirty="0"/>
           </a:p>
@@ -5445,7 +5445,7 @@
                 <a:ea typeface="Calibri" pitchFamily="34" charset="-122"/>
                 <a:cs typeface="Calibri" pitchFamily="34" charset="-120"/>
               </a:rPr>
-              <a:t>Week 3 · Fathering</a:t>
+              <a:t>Week 3 · Spiritual</a:t>
             </a:r>
             <a:endParaRPr lang="en-US" sz="1000" dirty="0"/>
           </a:p>
@@ -5583,7 +5583,7 @@
                 <a:ea typeface="Calibri" pitchFamily="34" charset="-122"/>
                 <a:cs typeface="Calibri" pitchFamily="34" charset="-120"/>
               </a:rPr>
-              <a:t>3 Questions for the Dinner Table</a:t>
+              <a:t>10-Min Scripture Study, You Lead</a:t>
             </a:r>
             <a:endParaRPr lang="en-US" sz="4000" dirty="0"/>
           </a:p>
@@ -5622,7 +5622,7 @@
                 <a:ea typeface="Calibri" pitchFamily="34" charset="-122"/>
                 <a:cs typeface="Calibri" pitchFamily="34" charset="-120"/>
               </a:rPr>
-              <a:t>Ask one tonight. Listen. Don't fix.</a:t>
+              <a:t>Claude is a study partner. Not a commentary. Not a pastor.</a:t>
             </a:r>
             <a:endParaRPr lang="en-US" sz="2000" dirty="0"/>
           </a:p>
@@ -5892,7 +5892,7 @@
                 <a:ea typeface="Calibri" pitchFamily="34" charset="-122"/>
                 <a:cs typeface="Calibri" pitchFamily="34" charset="-120"/>
               </a:rPr>
-              <a:t>Week 3 · Fathering</a:t>
+              <a:t>Week 3 · Spiritual</a:t>
             </a:r>
             <a:endParaRPr lang="en-US" sz="2200" dirty="0"/>
           </a:p>
@@ -5931,7 +5931,7 @@
                 <a:ea typeface="Calibri" pitchFamily="34" charset="-122"/>
                 <a:cs typeface="Calibri" pitchFamily="34" charset="-120"/>
               </a:rPr>
-              <a:t>Deuteronomy 6:6-7</a:t>
+              <a:t>Joshua 1:8</a:t>
             </a:r>
             <a:endParaRPr lang="en-US" sz="1800" dirty="0"/>
           </a:p>
@@ -6009,7 +6009,7 @@
                 <a:ea typeface="Calibri" pitchFamily="34" charset="-122"/>
                 <a:cs typeface="Calibri" pitchFamily="34" charset="-120"/>
               </a:rPr>
-              <a:t>Week 3 · Fathering · Task 1</a:t>
+              <a:t>Week 3 · Spiritual · Task 1</a:t>
             </a:r>
             <a:endParaRPr lang="en-US" sz="1000" dirty="0"/>
           </a:p>
@@ -6147,7 +6147,7 @@
                 <a:ea typeface="Calibri" pitchFamily="34" charset="-122"/>
                 <a:cs typeface="Calibri" pitchFamily="34" charset="-120"/>
               </a:rPr>
-              <a:t>Build a Family Rhythm Asset</a:t>
+              <a:t>Family Devotion Generator</a:t>
             </a:r>
             <a:endParaRPr lang="en-US" sz="4000" dirty="0"/>
           </a:p>
@@ -6186,7 +6186,7 @@
                 <a:ea typeface="Calibri" pitchFamily="34" charset="-122"/>
                 <a:cs typeface="Calibri" pitchFamily="34" charset="-120"/>
               </a:rPr>
-              <a:t>One concrete thing on the fridge by Friday.</a:t>
+              <a:t>Friday-night devo, built from a sermon. 10 minutes.</a:t>
             </a:r>
             <a:endParaRPr lang="en-US" sz="2000" dirty="0"/>
           </a:p>
@@ -6456,7 +6456,7 @@
                 <a:ea typeface="Calibri" pitchFamily="34" charset="-122"/>
                 <a:cs typeface="Calibri" pitchFamily="34" charset="-120"/>
               </a:rPr>
-              <a:t>Week 3 · Fathering</a:t>
+              <a:t>Week 3 · Spiritual</a:t>
             </a:r>
             <a:endParaRPr lang="en-US" sz="2200" dirty="0"/>
           </a:p>
@@ -6495,7 +6495,7 @@
                 <a:ea typeface="Calibri" pitchFamily="34" charset="-122"/>
                 <a:cs typeface="Calibri" pitchFamily="34" charset="-120"/>
               </a:rPr>
-              <a:t>Deuteronomy 6:6-7</a:t>
+              <a:t>Joshua 1:8</a:t>
             </a:r>
             <a:endParaRPr lang="en-US" sz="1800" dirty="0"/>
           </a:p>
@@ -6573,7 +6573,7 @@
                 <a:ea typeface="Calibri" pitchFamily="34" charset="-122"/>
                 <a:cs typeface="Calibri" pitchFamily="34" charset="-120"/>
               </a:rPr>
-              <a:t>Week 3 · Fathering · Task 2</a:t>
+              <a:t>Week 3 · Spiritual · Task 2</a:t>
             </a:r>
             <a:endParaRPr lang="en-US" sz="1000" dirty="0"/>
           </a:p>
@@ -6711,7 +6711,7 @@
                 <a:ea typeface="Calibri" pitchFamily="34" charset="-122"/>
                 <a:cs typeface="Calibri" pitchFamily="34" charset="-120"/>
               </a:rPr>
-              <a:t>Write Your Family AI Policy</a:t>
+              <a:t>Sermon Notes → Captain's Actions</a:t>
             </a:r>
             <a:endParaRPr lang="en-US" sz="4000" dirty="0"/>
           </a:p>
@@ -6750,7 +6750,7 @@
                 <a:ea typeface="Calibri" pitchFamily="34" charset="-122"/>
                 <a:cs typeface="Calibri" pitchFamily="34" charset="-120"/>
               </a:rPr>
-              <a:t>Built with the kids. What AI is for. What it never replaces.</a:t>
+              <a:t>Five actions from a sermon you sat under. Do one today.</a:t>
             </a:r>
             <a:endParaRPr lang="en-US" sz="2000" dirty="0"/>
           </a:p>
@@ -7020,7 +7020,7 @@
                 <a:ea typeface="Calibri" pitchFamily="34" charset="-122"/>
                 <a:cs typeface="Calibri" pitchFamily="34" charset="-120"/>
               </a:rPr>
-              <a:t>Week 3 · Fathering</a:t>
+              <a:t>Week 3 · Spiritual</a:t>
             </a:r>
             <a:endParaRPr lang="en-US" sz="2200" dirty="0"/>
           </a:p>
@@ -7059,7 +7059,7 @@
                 <a:ea typeface="Calibri" pitchFamily="34" charset="-122"/>
                 <a:cs typeface="Calibri" pitchFamily="34" charset="-120"/>
               </a:rPr>
-              <a:t>Deuteronomy 6:6-7</a:t>
+              <a:t>Joshua 1:8</a:t>
             </a:r>
             <a:endParaRPr lang="en-US" sz="1800" dirty="0"/>
           </a:p>
@@ -7137,7 +7137,7 @@
                 <a:ea typeface="Calibri" pitchFamily="34" charset="-122"/>
                 <a:cs typeface="Calibri" pitchFamily="34" charset="-120"/>
               </a:rPr>
-              <a:t>Week 3 · Fathering · Task 3</a:t>
+              <a:t>Week 3 · Spiritual · Task 3</a:t>
             </a:r>
             <a:endParaRPr lang="en-US" sz="1000" dirty="0"/>
           </a:p>
@@ -7275,7 +7275,7 @@
                 <a:ea typeface="Calibri" pitchFamily="34" charset="-122"/>
                 <a:cs typeface="Calibri" pitchFamily="34" charset="-120"/>
               </a:rPr>
-              <a:t>SPIRITUAL</a:t>
+              <a:t>HUSBANDING</a:t>
             </a:r>
             <a:endParaRPr lang="en-US" sz="7200" dirty="0"/>
           </a:p>
@@ -7339,7 +7339,7 @@
                 <a:ea typeface="Calibri" pitchFamily="34" charset="-122"/>
                 <a:cs typeface="Calibri" pitchFamily="34" charset="-120"/>
               </a:rPr>
-              <a:t>Walk with God. The captain's command flows from his communion.</a:t>
+              <a:t>Lead with love. The captain's first crew is one woman.</a:t>
             </a:r>
             <a:endParaRPr lang="en-US" sz="2400" dirty="0"/>
           </a:p>
@@ -7417,7 +7417,7 @@
                 <a:ea typeface="Calibri" pitchFamily="34" charset="-122"/>
                 <a:cs typeface="Calibri" pitchFamily="34" charset="-120"/>
               </a:rPr>
-              <a:t>Joshua 1:8</a:t>
+              <a:t>Ephesians 5:25-28</a:t>
             </a:r>
             <a:endParaRPr lang="en-US" sz="2000" dirty="0"/>
           </a:p>
@@ -7456,7 +7456,7 @@
                 <a:ea typeface="Calibri" pitchFamily="34" charset="-122"/>
                 <a:cs typeface="Calibri" pitchFamily="34" charset="-120"/>
               </a:rPr>
-              <a:t>Week 4 · Spiritual</a:t>
+              <a:t>Week 4 · Husbanding</a:t>
             </a:r>
             <a:endParaRPr lang="en-US" sz="1000" dirty="0"/>
           </a:p>
@@ -7594,7 +7594,7 @@
                 <a:ea typeface="Calibri" pitchFamily="34" charset="-122"/>
                 <a:cs typeface="Calibri" pitchFamily="34" charset="-120"/>
               </a:rPr>
-              <a:t>Sermon Notes → Captain's Actions</a:t>
+              <a:t>The 5-Minute Wife Audit</a:t>
             </a:r>
             <a:endParaRPr lang="en-US" sz="4000" dirty="0"/>
           </a:p>
@@ -7633,7 +7633,7 @@
                 <a:ea typeface="Calibri" pitchFamily="34" charset="-122"/>
                 <a:cs typeface="Calibri" pitchFamily="34" charset="-120"/>
               </a:rPr>
-              <a:t>Five actions from Sunday's sermon. Do one today.</a:t>
+              <a:t>A clean look at how you've actually been showing up.</a:t>
             </a:r>
             <a:endParaRPr lang="en-US" sz="2000" dirty="0"/>
           </a:p>
@@ -7903,7 +7903,7 @@
                 <a:ea typeface="Calibri" pitchFamily="34" charset="-122"/>
                 <a:cs typeface="Calibri" pitchFamily="34" charset="-120"/>
               </a:rPr>
-              <a:t>Week 4 · Spiritual</a:t>
+              <a:t>Week 4 · Husbanding</a:t>
             </a:r>
             <a:endParaRPr lang="en-US" sz="2200" dirty="0"/>
           </a:p>
@@ -7942,7 +7942,7 @@
                 <a:ea typeface="Calibri" pitchFamily="34" charset="-122"/>
                 <a:cs typeface="Calibri" pitchFamily="34" charset="-120"/>
               </a:rPr>
-              <a:t>Joshua 1:8</a:t>
+              <a:t>Ephesians 5:25-28</a:t>
             </a:r>
             <a:endParaRPr lang="en-US" sz="1800" dirty="0"/>
           </a:p>
@@ -8020,7 +8020,7 @@
                 <a:ea typeface="Calibri" pitchFamily="34" charset="-122"/>
                 <a:cs typeface="Calibri" pitchFamily="34" charset="-120"/>
               </a:rPr>
-              <a:t>Week 4 · Spiritual · Task 1</a:t>
+              <a:t>Week 4 · Husbanding · Task 1</a:t>
             </a:r>
             <a:endParaRPr lang="en-US" sz="1000" dirty="0"/>
           </a:p>
@@ -8158,7 +8158,7 @@
                 <a:ea typeface="Calibri" pitchFamily="34" charset="-122"/>
                 <a:cs typeface="Calibri" pitchFamily="34" charset="-120"/>
               </a:rPr>
-              <a:t>10-Min Scripture Study, You Lead</a:t>
+              <a:t>Prep One Hard Conversation</a:t>
             </a:r>
             <a:endParaRPr lang="en-US" sz="4000" dirty="0"/>
           </a:p>
@@ -8197,7 +8197,7 @@
                 <a:ea typeface="Calibri" pitchFamily="34" charset="-122"/>
                 <a:cs typeface="Calibri" pitchFamily="34" charset="-120"/>
               </a:rPr>
-              <a:t>Claude is a study partner. Not a commentary. Not a pastor.</a:t>
+              <a:t>AI prepares the captain. The captain shows up.</a:t>
             </a:r>
             <a:endParaRPr lang="en-US" sz="2000" dirty="0"/>
           </a:p>
@@ -8467,7 +8467,7 @@
                 <a:ea typeface="Calibri" pitchFamily="34" charset="-122"/>
                 <a:cs typeface="Calibri" pitchFamily="34" charset="-120"/>
               </a:rPr>
-              <a:t>Week 4 · Spiritual</a:t>
+              <a:t>Week 4 · Husbanding</a:t>
             </a:r>
             <a:endParaRPr lang="en-US" sz="2200" dirty="0"/>
           </a:p>
@@ -8506,7 +8506,7 @@
                 <a:ea typeface="Calibri" pitchFamily="34" charset="-122"/>
                 <a:cs typeface="Calibri" pitchFamily="34" charset="-120"/>
               </a:rPr>
-              <a:t>Joshua 1:8</a:t>
+              <a:t>Ephesians 5:25-28</a:t>
             </a:r>
             <a:endParaRPr lang="en-US" sz="1800" dirty="0"/>
           </a:p>
@@ -8584,7 +8584,7 @@
                 <a:ea typeface="Calibri" pitchFamily="34" charset="-122"/>
                 <a:cs typeface="Calibri" pitchFamily="34" charset="-120"/>
               </a:rPr>
-              <a:t>Week 4 · Spiritual · Task 2</a:t>
+              <a:t>Week 4 · Husbanding · Task 2</a:t>
             </a:r>
             <a:endParaRPr lang="en-US" sz="1000" dirty="0"/>
           </a:p>
@@ -8722,7 +8722,7 @@
                 <a:ea typeface="Calibri" pitchFamily="34" charset="-122"/>
                 <a:cs typeface="Calibri" pitchFamily="34" charset="-120"/>
               </a:rPr>
-              <a:t>Family Devotion Generator</a:t>
+              <a:t>Letter to Your Wife</a:t>
             </a:r>
             <a:endParaRPr lang="en-US" sz="4000" dirty="0"/>
           </a:p>
@@ -8761,7 +8761,7 @@
                 <a:ea typeface="Calibri" pitchFamily="34" charset="-122"/>
                 <a:cs typeface="Calibri" pitchFamily="34" charset="-120"/>
               </a:rPr>
-              <a:t>Friday-night devo, built from Sunday's sermon. 10 minutes.</a:t>
+              <a:t>One page. AI polishes grammar. You sign. You hand it over.</a:t>
             </a:r>
             <a:endParaRPr lang="en-US" sz="2000" dirty="0"/>
           </a:p>
@@ -9031,7 +9031,7 @@
                 <a:ea typeface="Calibri" pitchFamily="34" charset="-122"/>
                 <a:cs typeface="Calibri" pitchFamily="34" charset="-120"/>
               </a:rPr>
-              <a:t>Week 4 · Spiritual</a:t>
+              <a:t>Week 4 · Husbanding</a:t>
             </a:r>
             <a:endParaRPr lang="en-US" sz="2200" dirty="0"/>
           </a:p>
@@ -9070,7 +9070,7 @@
                 <a:ea typeface="Calibri" pitchFamily="34" charset="-122"/>
                 <a:cs typeface="Calibri" pitchFamily="34" charset="-120"/>
               </a:rPr>
-              <a:t>Joshua 1:8</a:t>
+              <a:t>Ephesians 5:25-28</a:t>
             </a:r>
             <a:endParaRPr lang="en-US" sz="1800" dirty="0"/>
           </a:p>
@@ -9148,7 +9148,7 @@
                 <a:ea typeface="Calibri" pitchFamily="34" charset="-122"/>
                 <a:cs typeface="Calibri" pitchFamily="34" charset="-120"/>
               </a:rPr>
-              <a:t>Week 4 · Spiritual · Task 3</a:t>
+              <a:t>Week 4 · Husbanding · Task 3</a:t>
             </a:r>
             <a:endParaRPr lang="en-US" sz="1000" dirty="0"/>
           </a:p>
@@ -9886,7 +9886,7 @@
                 <a:ea typeface="Calibri" pitchFamily="34" charset="-122"/>
                 <a:cs typeface="Calibri" pitchFamily="34" charset="-120"/>
               </a:rPr>
-              <a:t>BODY</a:t>
+              <a:t>FATHERING</a:t>
             </a:r>
             <a:endParaRPr lang="en-US" sz="7200" dirty="0"/>
           </a:p>
@@ -9950,7 +9950,7 @@
                 <a:ea typeface="Calibri" pitchFamily="34" charset="-122"/>
                 <a:cs typeface="Calibri" pitchFamily="34" charset="-120"/>
               </a:rPr>
-              <a:t>Steward the temple. The captain trains the body that carries the load.</a:t>
+              <a:t>Train up your children. AI assists; the captain disciples.</a:t>
             </a:r>
             <a:endParaRPr lang="en-US" sz="2400" dirty="0"/>
           </a:p>
@@ -10028,7 +10028,7 @@
                 <a:ea typeface="Calibri" pitchFamily="34" charset="-122"/>
                 <a:cs typeface="Calibri" pitchFamily="34" charset="-120"/>
               </a:rPr>
-              <a:t>1 Corinthians 6:19-20</a:t>
+              <a:t>Deuteronomy 6:6-7</a:t>
             </a:r>
             <a:endParaRPr lang="en-US" sz="2000" dirty="0"/>
           </a:p>
@@ -10067,7 +10067,7 @@
                 <a:ea typeface="Calibri" pitchFamily="34" charset="-122"/>
                 <a:cs typeface="Calibri" pitchFamily="34" charset="-120"/>
               </a:rPr>
-              <a:t>Week 5 · Body</a:t>
+              <a:t>Week 5 · Fathering</a:t>
             </a:r>
             <a:endParaRPr lang="en-US" sz="1000" dirty="0"/>
           </a:p>
@@ -10205,7 +10205,7 @@
                 <a:ea typeface="Calibri" pitchFamily="34" charset="-122"/>
                 <a:cs typeface="Calibri" pitchFamily="34" charset="-120"/>
               </a:rPr>
-              <a:t>Weekly Movement Practice</a:t>
+              <a:t>3 Questions for the Dinner Table</a:t>
             </a:r>
             <a:endParaRPr lang="en-US" sz="4000" dirty="0"/>
           </a:p>
@@ -10244,7 +10244,7 @@
                 <a:ea typeface="Calibri" pitchFamily="34" charset="-122"/>
                 <a:cs typeface="Calibri" pitchFamily="34" charset="-120"/>
               </a:rPr>
-              <a:t>3x strength + 2x walking. On the calendar. Not a wish.</a:t>
+              <a:t>Ask one tonight. Listen. Don't fix.</a:t>
             </a:r>
             <a:endParaRPr lang="en-US" sz="2000" dirty="0"/>
           </a:p>
@@ -10514,7 +10514,7 @@
                 <a:ea typeface="Calibri" pitchFamily="34" charset="-122"/>
                 <a:cs typeface="Calibri" pitchFamily="34" charset="-120"/>
               </a:rPr>
-              <a:t>Week 5 · Body</a:t>
+              <a:t>Week 5 · Fathering</a:t>
             </a:r>
             <a:endParaRPr lang="en-US" sz="2200" dirty="0"/>
           </a:p>
@@ -10553,7 +10553,7 @@
                 <a:ea typeface="Calibri" pitchFamily="34" charset="-122"/>
                 <a:cs typeface="Calibri" pitchFamily="34" charset="-120"/>
               </a:rPr>
-              <a:t>1 Corinthians 6:19-20</a:t>
+              <a:t>Deuteronomy 6:6-7</a:t>
             </a:r>
             <a:endParaRPr lang="en-US" sz="1800" dirty="0"/>
           </a:p>
@@ -10631,7 +10631,7 @@
                 <a:ea typeface="Calibri" pitchFamily="34" charset="-122"/>
                 <a:cs typeface="Calibri" pitchFamily="34" charset="-120"/>
               </a:rPr>
-              <a:t>Week 5 · Body · Task 1</a:t>
+              <a:t>Week 5 · Fathering · Task 1</a:t>
             </a:r>
             <a:endParaRPr lang="en-US" sz="1000" dirty="0"/>
           </a:p>
@@ -10769,7 +10769,7 @@
                 <a:ea typeface="Calibri" pitchFamily="34" charset="-122"/>
                 <a:cs typeface="Calibri" pitchFamily="34" charset="-120"/>
               </a:rPr>
-              <a:t>Captain's Meal Plan</a:t>
+              <a:t>Build a Family Rhythm Asset</a:t>
             </a:r>
             <a:endParaRPr lang="en-US" sz="4000" dirty="0"/>
           </a:p>
@@ -10808,7 +10808,7 @@
                 <a:ea typeface="Calibri" pitchFamily="34" charset="-122"/>
                 <a:cs typeface="Calibri" pitchFamily="34" charset="-120"/>
               </a:rPr>
-              <a:t>Protein-forward one-week plan. AI drafts. Shopper collaborates.</a:t>
+              <a:t>One concrete thing on the fridge by Friday.</a:t>
             </a:r>
             <a:endParaRPr lang="en-US" sz="2000" dirty="0"/>
           </a:p>
@@ -11078,7 +11078,7 @@
                 <a:ea typeface="Calibri" pitchFamily="34" charset="-122"/>
                 <a:cs typeface="Calibri" pitchFamily="34" charset="-120"/>
               </a:rPr>
-              <a:t>Week 5 · Body</a:t>
+              <a:t>Week 5 · Fathering</a:t>
             </a:r>
             <a:endParaRPr lang="en-US" sz="2200" dirty="0"/>
           </a:p>
@@ -11117,7 +11117,7 @@
                 <a:ea typeface="Calibri" pitchFamily="34" charset="-122"/>
                 <a:cs typeface="Calibri" pitchFamily="34" charset="-120"/>
               </a:rPr>
-              <a:t>1 Corinthians 6:19-20</a:t>
+              <a:t>Deuteronomy 6:6-7</a:t>
             </a:r>
             <a:endParaRPr lang="en-US" sz="1800" dirty="0"/>
           </a:p>
@@ -11195,7 +11195,7 @@
                 <a:ea typeface="Calibri" pitchFamily="34" charset="-122"/>
                 <a:cs typeface="Calibri" pitchFamily="34" charset="-120"/>
               </a:rPr>
-              <a:t>Week 5 · Body · Task 2</a:t>
+              <a:t>Week 5 · Fathering · Task 2</a:t>
             </a:r>
             <a:endParaRPr lang="en-US" sz="1000" dirty="0"/>
           </a:p>
@@ -11333,7 +11333,7 @@
                 <a:ea typeface="Calibri" pitchFamily="34" charset="-122"/>
                 <a:cs typeface="Calibri" pitchFamily="34" charset="-120"/>
               </a:rPr>
-              <a:t>5-Night Sleep Audit</a:t>
+              <a:t>Write Your Family AI Policy</a:t>
             </a:r>
             <a:endParaRPr lang="en-US" sz="4000" dirty="0"/>
           </a:p>
@@ -11372,7 +11372,7 @@
                 <a:ea typeface="Calibri" pitchFamily="34" charset="-122"/>
                 <a:cs typeface="Calibri" pitchFamily="34" charset="-120"/>
               </a:rPr>
-              <a:t>Log 5 nights. AI summarizes. Fix one variable next week.</a:t>
+              <a:t>Built with the kids. What AI is for. What it never replaces.</a:t>
             </a:r>
             <a:endParaRPr lang="en-US" sz="2000" dirty="0"/>
           </a:p>
@@ -11642,7 +11642,7 @@
                 <a:ea typeface="Calibri" pitchFamily="34" charset="-122"/>
                 <a:cs typeface="Calibri" pitchFamily="34" charset="-120"/>
               </a:rPr>
-              <a:t>Week 5 · Body</a:t>
+              <a:t>Week 5 · Fathering</a:t>
             </a:r>
             <a:endParaRPr lang="en-US" sz="2200" dirty="0"/>
           </a:p>
@@ -11681,7 +11681,7 @@
                 <a:ea typeface="Calibri" pitchFamily="34" charset="-122"/>
                 <a:cs typeface="Calibri" pitchFamily="34" charset="-120"/>
               </a:rPr>
-              <a:t>1 Corinthians 6:19-20</a:t>
+              <a:t>Deuteronomy 6:6-7</a:t>
             </a:r>
             <a:endParaRPr lang="en-US" sz="1800" dirty="0"/>
           </a:p>
@@ -11759,7 +11759,7 @@
                 <a:ea typeface="Calibri" pitchFamily="34" charset="-122"/>
                 <a:cs typeface="Calibri" pitchFamily="34" charset="-120"/>
               </a:rPr>
-              <a:t>Week 5 · Body · Task 3</a:t>
+              <a:t>Week 5 · Fathering · Task 3</a:t>
             </a:r>
             <a:endParaRPr lang="en-US" sz="1000" dirty="0"/>
           </a:p>
@@ -11897,7 +11897,7 @@
                 <a:ea typeface="Calibri" pitchFamily="34" charset="-122"/>
                 <a:cs typeface="Calibri" pitchFamily="34" charset="-120"/>
               </a:rPr>
-              <a:t>FINANCES</a:t>
+              <a:t>FINANCE</a:t>
             </a:r>
             <a:endParaRPr lang="en-US" sz="7200" dirty="0"/>
           </a:p>
@@ -12078,7 +12078,7 @@
                 <a:ea typeface="Calibri" pitchFamily="34" charset="-122"/>
                 <a:cs typeface="Calibri" pitchFamily="34" charset="-120"/>
               </a:rPr>
-              <a:t>Week 6 · Finances</a:t>
+              <a:t>Week 6 · Finance</a:t>
             </a:r>
             <a:endParaRPr lang="en-US" sz="1000" dirty="0"/>
           </a:p>
@@ -12525,7 +12525,7 @@
                 <a:ea typeface="Calibri" pitchFamily="34" charset="-122"/>
                 <a:cs typeface="Calibri" pitchFamily="34" charset="-120"/>
               </a:rPr>
-              <a:t>Week 6 · Finances</a:t>
+              <a:t>Week 6 · Finance</a:t>
             </a:r>
             <a:endParaRPr lang="en-US" sz="2200" dirty="0"/>
           </a:p>
@@ -12642,7 +12642,7 @@
                 <a:ea typeface="Calibri" pitchFamily="34" charset="-122"/>
                 <a:cs typeface="Calibri" pitchFamily="34" charset="-120"/>
               </a:rPr>
-              <a:t>Week 6 · Finances · Task 1</a:t>
+              <a:t>Week 6 · Finance · Task 1</a:t>
             </a:r>
             <a:endParaRPr lang="en-US" sz="1000" dirty="0"/>
           </a:p>
@@ -13089,7 +13089,7 @@
                 <a:ea typeface="Calibri" pitchFamily="34" charset="-122"/>
                 <a:cs typeface="Calibri" pitchFamily="34" charset="-120"/>
               </a:rPr>
-              <a:t>Week 6 · Finances</a:t>
+              <a:t>Week 6 · Finance</a:t>
             </a:r>
             <a:endParaRPr lang="en-US" sz="2200" dirty="0"/>
           </a:p>
@@ -13206,7 +13206,7 @@
                 <a:ea typeface="Calibri" pitchFamily="34" charset="-122"/>
                 <a:cs typeface="Calibri" pitchFamily="34" charset="-120"/>
               </a:rPr>
-              <a:t>Week 6 · Finances · Task 2</a:t>
+              <a:t>Week 6 · Finance · Task 2</a:t>
             </a:r>
             <a:endParaRPr lang="en-US" sz="1000" dirty="0"/>
           </a:p>
@@ -13653,7 +13653,7 @@
                 <a:ea typeface="Calibri" pitchFamily="34" charset="-122"/>
                 <a:cs typeface="Calibri" pitchFamily="34" charset="-120"/>
               </a:rPr>
-              <a:t>Week 6 · Finances</a:t>
+              <a:t>Week 6 · Finance</a:t>
             </a:r>
             <a:endParaRPr lang="en-US" sz="2200" dirty="0"/>
           </a:p>
@@ -13770,7 +13770,7 @@
                 <a:ea typeface="Calibri" pitchFamily="34" charset="-122"/>
                 <a:cs typeface="Calibri" pitchFamily="34" charset="-120"/>
               </a:rPr>
-              <a:t>Week 6 · Finances · Task 3</a:t>
+              <a:t>Week 6 · Finance · Task 3</a:t>
             </a:r>
             <a:endParaRPr lang="en-US" sz="1000" dirty="0"/>
           </a:p>
@@ -14919,7 +14919,7 @@
                 <a:ea typeface="Calibri" pitchFamily="34" charset="-122"/>
                 <a:cs typeface="Calibri" pitchFamily="34" charset="-120"/>
               </a:rPr>
-              <a:t>VISIONING</a:t>
+              <a:t>VISION</a:t>
             </a:r>
             <a:endParaRPr lang="en-US" sz="1800" dirty="0"/>
           </a:p>
@@ -15086,7 +15086,7 @@
                 <a:ea typeface="Calibri" pitchFamily="34" charset="-122"/>
                 <a:cs typeface="Calibri" pitchFamily="34" charset="-120"/>
               </a:rPr>
-              <a:t>HUSBANDING</a:t>
+              <a:t>BODY</a:t>
             </a:r>
             <a:endParaRPr lang="en-US" sz="1800" dirty="0"/>
           </a:p>
@@ -15125,7 +15125,7 @@
                 <a:ea typeface="Calibri" pitchFamily="34" charset="-122"/>
                 <a:cs typeface="Calibri" pitchFamily="34" charset="-120"/>
               </a:rPr>
-              <a:t>Ephesians 5:25-28</a:t>
+              <a:t>1 Corinthians 6:19-20</a:t>
             </a:r>
             <a:endParaRPr lang="en-US" sz="1100" dirty="0"/>
           </a:p>
@@ -15253,7 +15253,7 @@
                 <a:ea typeface="Calibri" pitchFamily="34" charset="-122"/>
                 <a:cs typeface="Calibri" pitchFamily="34" charset="-120"/>
               </a:rPr>
-              <a:t>FATHERING</a:t>
+              <a:t>SPIRITUAL</a:t>
             </a:r>
             <a:endParaRPr lang="en-US" sz="1800" dirty="0"/>
           </a:p>
@@ -15292,7 +15292,7 @@
                 <a:ea typeface="Calibri" pitchFamily="34" charset="-122"/>
                 <a:cs typeface="Calibri" pitchFamily="34" charset="-120"/>
               </a:rPr>
-              <a:t>Deuteronomy 6:6-7</a:t>
+              <a:t>Joshua 1:8</a:t>
             </a:r>
             <a:endParaRPr lang="en-US" sz="1100" dirty="0"/>
           </a:p>
@@ -15420,7 +15420,7 @@
                 <a:ea typeface="Calibri" pitchFamily="34" charset="-122"/>
                 <a:cs typeface="Calibri" pitchFamily="34" charset="-120"/>
               </a:rPr>
-              <a:t>SPIRITUAL</a:t>
+              <a:t>HUSBANDING</a:t>
             </a:r>
             <a:endParaRPr lang="en-US" sz="1800" dirty="0"/>
           </a:p>
@@ -15459,7 +15459,7 @@
                 <a:ea typeface="Calibri" pitchFamily="34" charset="-122"/>
                 <a:cs typeface="Calibri" pitchFamily="34" charset="-120"/>
               </a:rPr>
-              <a:t>Joshua 1:8</a:t>
+              <a:t>Ephesians 5:25-28</a:t>
             </a:r>
             <a:endParaRPr lang="en-US" sz="1100" dirty="0"/>
           </a:p>
@@ -15587,7 +15587,7 @@
                 <a:ea typeface="Calibri" pitchFamily="34" charset="-122"/>
                 <a:cs typeface="Calibri" pitchFamily="34" charset="-120"/>
               </a:rPr>
-              <a:t>BODY</a:t>
+              <a:t>FATHERING</a:t>
             </a:r>
             <a:endParaRPr lang="en-US" sz="1800" dirty="0"/>
           </a:p>
@@ -15626,7 +15626,7 @@
                 <a:ea typeface="Calibri" pitchFamily="34" charset="-122"/>
                 <a:cs typeface="Calibri" pitchFamily="34" charset="-120"/>
               </a:rPr>
-              <a:t>1 Corinthians 6:19-20</a:t>
+              <a:t>Deuteronomy 6:6-7</a:t>
             </a:r>
             <a:endParaRPr lang="en-US" sz="1100" dirty="0"/>
           </a:p>
@@ -15754,7 +15754,7 @@
                 <a:ea typeface="Calibri" pitchFamily="34" charset="-122"/>
                 <a:cs typeface="Calibri" pitchFamily="34" charset="-120"/>
               </a:rPr>
-              <a:t>FINANCES</a:t>
+              <a:t>FINANCE</a:t>
             </a:r>
             <a:endParaRPr lang="en-US" sz="1800" dirty="0"/>
           </a:p>
@@ -17432,7 +17432,7 @@
                 <a:ea typeface="Calibri" pitchFamily="34" charset="-122"/>
                 <a:cs typeface="Calibri" pitchFamily="34" charset="-120"/>
               </a:rPr>
-              <a:t>Visioning</a:t>
+              <a:t>Vision</a:t>
             </a:r>
             <a:endParaRPr lang="en-US" sz="1800" dirty="0"/>
           </a:p>
@@ -17599,7 +17599,7 @@
                 <a:ea typeface="Calibri" pitchFamily="34" charset="-122"/>
                 <a:cs typeface="Calibri" pitchFamily="34" charset="-120"/>
               </a:rPr>
-              <a:t>Husbanding</a:t>
+              <a:t>Body</a:t>
             </a:r>
             <a:endParaRPr lang="en-US" sz="1800" dirty="0"/>
           </a:p>
@@ -17766,7 +17766,7 @@
                 <a:ea typeface="Calibri" pitchFamily="34" charset="-122"/>
                 <a:cs typeface="Calibri" pitchFamily="34" charset="-120"/>
               </a:rPr>
-              <a:t>Fathering</a:t>
+              <a:t>Spiritual</a:t>
             </a:r>
             <a:endParaRPr lang="en-US" sz="1800" dirty="0"/>
           </a:p>
@@ -17933,7 +17933,7 @@
                 <a:ea typeface="Calibri" pitchFamily="34" charset="-122"/>
                 <a:cs typeface="Calibri" pitchFamily="34" charset="-120"/>
               </a:rPr>
-              <a:t>Spiritual</a:t>
+              <a:t>Husbanding</a:t>
             </a:r>
             <a:endParaRPr lang="en-US" sz="1800" dirty="0"/>
           </a:p>
@@ -18100,7 +18100,7 @@
                 <a:ea typeface="Calibri" pitchFamily="34" charset="-122"/>
                 <a:cs typeface="Calibri" pitchFamily="34" charset="-120"/>
               </a:rPr>
-              <a:t>Body</a:t>
+              <a:t>Fathering</a:t>
             </a:r>
             <a:endParaRPr lang="en-US" sz="1800" dirty="0"/>
           </a:p>
@@ -18267,7 +18267,7 @@
                 <a:ea typeface="Calibri" pitchFamily="34" charset="-122"/>
                 <a:cs typeface="Calibri" pitchFamily="34" charset="-120"/>
               </a:rPr>
-              <a:t>Finances</a:t>
+              <a:t>Finance</a:t>
             </a:r>
             <a:endParaRPr lang="en-US" sz="1800" dirty="0"/>
           </a:p>
@@ -19501,7 +19501,7 @@
                 <a:ea typeface="Calibri" pitchFamily="34" charset="-122"/>
                 <a:cs typeface="Calibri" pitchFamily="34" charset="-120"/>
               </a:rPr>
-              <a:t>VISIONING</a:t>
+              <a:t>VISION</a:t>
             </a:r>
             <a:endParaRPr lang="en-US" sz="7200" dirty="0"/>
           </a:p>
@@ -19682,7 +19682,7 @@
                 <a:ea typeface="Calibri" pitchFamily="34" charset="-122"/>
                 <a:cs typeface="Calibri" pitchFamily="34" charset="-120"/>
               </a:rPr>
-              <a:t>Week 1 · Visioning</a:t>
+              <a:t>Week 1 · Vision</a:t>
             </a:r>
             <a:endParaRPr lang="en-US" sz="1000" dirty="0"/>
           </a:p>
@@ -20129,7 +20129,7 @@
                 <a:ea typeface="Calibri" pitchFamily="34" charset="-122"/>
                 <a:cs typeface="Calibri" pitchFamily="34" charset="-120"/>
               </a:rPr>
-              <a:t>Week 1 · Visioning</a:t>
+              <a:t>Week 1 · Vision</a:t>
             </a:r>
             <a:endParaRPr lang="en-US" sz="2200" dirty="0"/>
           </a:p>
@@ -20246,7 +20246,7 @@
                 <a:ea typeface="Calibri" pitchFamily="34" charset="-122"/>
                 <a:cs typeface="Calibri" pitchFamily="34" charset="-120"/>
               </a:rPr>
-              <a:t>Week 1 · Visioning · Task 1</a:t>
+              <a:t>Week 1 · Vision · Task 1</a:t>
             </a:r>
             <a:endParaRPr lang="en-US" sz="1000" dirty="0"/>
           </a:p>
@@ -20693,7 +20693,7 @@
                 <a:ea typeface="Calibri" pitchFamily="34" charset="-122"/>
                 <a:cs typeface="Calibri" pitchFamily="34" charset="-120"/>
               </a:rPr>
-              <a:t>Week 1 · Visioning</a:t>
+              <a:t>Week 1 · Vision</a:t>
             </a:r>
             <a:endParaRPr lang="en-US" sz="2200" dirty="0"/>
           </a:p>
@@ -20810,7 +20810,7 @@
                 <a:ea typeface="Calibri" pitchFamily="34" charset="-122"/>
                 <a:cs typeface="Calibri" pitchFamily="34" charset="-120"/>
               </a:rPr>
-              <a:t>Week 1 · Visioning · Task 2</a:t>
+              <a:t>Week 1 · Vision · Task 2</a:t>
             </a:r>
             <a:endParaRPr lang="en-US" sz="1000" dirty="0"/>
           </a:p>
@@ -21257,7 +21257,7 @@
                 <a:ea typeface="Calibri" pitchFamily="34" charset="-122"/>
                 <a:cs typeface="Calibri" pitchFamily="34" charset="-120"/>
               </a:rPr>
-              <a:t>Week 1 · Visioning</a:t>
+              <a:t>Week 1 · Vision</a:t>
             </a:r>
             <a:endParaRPr lang="en-US" sz="2200" dirty="0"/>
           </a:p>
@@ -21374,7 +21374,7 @@
                 <a:ea typeface="Calibri" pitchFamily="34" charset="-122"/>
                 <a:cs typeface="Calibri" pitchFamily="34" charset="-120"/>
               </a:rPr>
-              <a:t>Week 1 · Visioning · Task 3</a:t>
+              <a:t>Week 1 · Vision · Task 3</a:t>
             </a:r>
             <a:endParaRPr lang="en-US" sz="1000" dirty="0"/>
           </a:p>
@@ -21512,7 +21512,7 @@
                 <a:ea typeface="Calibri" pitchFamily="34" charset="-122"/>
                 <a:cs typeface="Calibri" pitchFamily="34" charset="-120"/>
               </a:rPr>
-              <a:t>HUSBANDING</a:t>
+              <a:t>BODY</a:t>
             </a:r>
             <a:endParaRPr lang="en-US" sz="7200" dirty="0"/>
           </a:p>
@@ -21576,7 +21576,7 @@
                 <a:ea typeface="Calibri" pitchFamily="34" charset="-122"/>
                 <a:cs typeface="Calibri" pitchFamily="34" charset="-120"/>
               </a:rPr>
-              <a:t>Lead with love. The captain's first crew is one woman.</a:t>
+              <a:t>Steward the temple. The captain trains the body that carries the load.</a:t>
             </a:r>
             <a:endParaRPr lang="en-US" sz="2400" dirty="0"/>
           </a:p>
@@ -21654,7 +21654,7 @@
                 <a:ea typeface="Calibri" pitchFamily="34" charset="-122"/>
                 <a:cs typeface="Calibri" pitchFamily="34" charset="-120"/>
               </a:rPr>
-              <a:t>Ephesians 5:25-28</a:t>
+              <a:t>1 Corinthians 6:19-20</a:t>
             </a:r>
             <a:endParaRPr lang="en-US" sz="2000" dirty="0"/>
           </a:p>
@@ -21693,7 +21693,7 @@
                 <a:ea typeface="Calibri" pitchFamily="34" charset="-122"/>
                 <a:cs typeface="Calibri" pitchFamily="34" charset="-120"/>
               </a:rPr>
-              <a:t>Week 2 · Husbanding</a:t>
+              <a:t>Week 2 · Body</a:t>
             </a:r>
             <a:endParaRPr lang="en-US" sz="1000" dirty="0"/>
           </a:p>
@@ -21831,7 +21831,7 @@
                 <a:ea typeface="Calibri" pitchFamily="34" charset="-122"/>
                 <a:cs typeface="Calibri" pitchFamily="34" charset="-120"/>
               </a:rPr>
-              <a:t>The 5-Minute Wife Audit</a:t>
+              <a:t>Weekly Movement Practice</a:t>
             </a:r>
             <a:endParaRPr lang="en-US" sz="4000" dirty="0"/>
           </a:p>
@@ -21870,7 +21870,7 @@
                 <a:ea typeface="Calibri" pitchFamily="34" charset="-122"/>
                 <a:cs typeface="Calibri" pitchFamily="34" charset="-120"/>
               </a:rPr>
-              <a:t>A clean look at how you've actually been showing up.</a:t>
+              <a:t>3x strength + 2x walking. On the calendar. Not a wish.</a:t>
             </a:r>
             <a:endParaRPr lang="en-US" sz="2000" dirty="0"/>
           </a:p>
@@ -22140,7 +22140,7 @@
                 <a:ea typeface="Calibri" pitchFamily="34" charset="-122"/>
                 <a:cs typeface="Calibri" pitchFamily="34" charset="-120"/>
               </a:rPr>
-              <a:t>Week 2 · Husbanding</a:t>
+              <a:t>Week 2 · Body</a:t>
             </a:r>
             <a:endParaRPr lang="en-US" sz="2200" dirty="0"/>
           </a:p>
@@ -22179,7 +22179,7 @@
                 <a:ea typeface="Calibri" pitchFamily="34" charset="-122"/>
                 <a:cs typeface="Calibri" pitchFamily="34" charset="-120"/>
               </a:rPr>
-              <a:t>Ephesians 5:25-28</a:t>
+              <a:t>1 Corinthians 6:19-20</a:t>
             </a:r>
             <a:endParaRPr lang="en-US" sz="1800" dirty="0"/>
           </a:p>
@@ -22257,7 +22257,7 @@
                 <a:ea typeface="Calibri" pitchFamily="34" charset="-122"/>
                 <a:cs typeface="Calibri" pitchFamily="34" charset="-120"/>
               </a:rPr>
-              <a:t>Week 2 · Husbanding · Task 1</a:t>
+              <a:t>Week 2 · Body · Task 1</a:t>
             </a:r>
             <a:endParaRPr lang="en-US" sz="1000" dirty="0"/>
           </a:p>

</xml_diff>